<commit_message>
fix(demo): show native runtimes and align M38 presentation
</commit_message>
<xml_diff>
--- a/docs/slides/M38-Demo-Day.pptx
+++ b/docs/slides/M38-Demo-Day.pptx
@@ -2,19 +2,18 @@
 <file path=ppt/presentation.xml><?xml version="1.0" encoding="utf-8"?>
 <p:presentation xmlns:p="http://schemas.openxmlformats.org/presentationml/2006/main">
   <p:sldMasterIdLst>
-    <p:sldMasterId xmlns:r="http://schemas.openxmlformats.org/officeDocument/2006/relationships" id="2147483648" r:id="R3371f08e16b0407b"/>
+    <p:sldMasterId xmlns:r="http://schemas.openxmlformats.org/officeDocument/2006/relationships" id="2147483648" r:id="Rf857904dd2ce491c"/>
   </p:sldMasterIdLst>
   <p:notesMasterIdLst>
-    <p:notesMasterId xmlns:r="http://schemas.openxmlformats.org/officeDocument/2006/relationships" r:id="R4d21ff09b4994345"/>
+    <p:notesMasterId xmlns:r="http://schemas.openxmlformats.org/officeDocument/2006/relationships" r:id="R34e7bc8e25fd4350"/>
   </p:notesMasterIdLst>
   <p:sldIdLst>
-    <p:sldId xmlns:r="http://schemas.openxmlformats.org/officeDocument/2006/relationships" id="256" r:id="R173d86bb10cd44f5"/>
-    <p:sldId xmlns:r="http://schemas.openxmlformats.org/officeDocument/2006/relationships" id="257" r:id="Rd583b470365442e7"/>
-    <p:sldId xmlns:r="http://schemas.openxmlformats.org/officeDocument/2006/relationships" id="258" r:id="Rfdce93ccbb59411c"/>
-    <p:sldId xmlns:r="http://schemas.openxmlformats.org/officeDocument/2006/relationships" id="259" r:id="R45283b787f944821"/>
-    <p:sldId xmlns:r="http://schemas.openxmlformats.org/officeDocument/2006/relationships" id="260" r:id="Re749f3a9baf946e1"/>
-    <p:sldId xmlns:r="http://schemas.openxmlformats.org/officeDocument/2006/relationships" id="261" r:id="Rab25a74927ab4a35"/>
-    <p:sldId xmlns:r="http://schemas.openxmlformats.org/officeDocument/2006/relationships" id="262" r:id="R041accf144d9459a"/>
+    <p:sldId xmlns:r="http://schemas.openxmlformats.org/officeDocument/2006/relationships" id="256" r:id="R9ac87cbd041e496c"/>
+    <p:sldId xmlns:r="http://schemas.openxmlformats.org/officeDocument/2006/relationships" id="257" r:id="Rf63dd86dd1804505"/>
+    <p:sldId xmlns:r="http://schemas.openxmlformats.org/officeDocument/2006/relationships" id="258" r:id="R42cd8d38dac345aa"/>
+    <p:sldId xmlns:r="http://schemas.openxmlformats.org/officeDocument/2006/relationships" id="259" r:id="R7d2378d54a0f4eb2"/>
+    <p:sldId xmlns:r="http://schemas.openxmlformats.org/officeDocument/2006/relationships" id="260" r:id="R3a641f9ea5f84c40"/>
+    <p:sldId xmlns:r="http://schemas.openxmlformats.org/officeDocument/2006/relationships" id="261" r:id="R8311b212f3bb42fb"/>
   </p:sldIdLst>
   <p:sldSz cx="12192000" cy="6858000"/>
   <p:notesSz cx="6858000" cy="9144000"/>
@@ -888,86 +887,6 @@
 </p:notes>
 </file>
 
-<file path=ppt/notesSlides/notesSlide7.xml><?xml version="1.0" encoding="utf-8"?>
-<p:notes xmlns:p="http://schemas.openxmlformats.org/presentationml/2006/main">
-  <p:cSld>
-    <p:spTree>
-      <p:nvGrpSpPr>
-        <p:cNvPr id="1" name=""/>
-        <p:cNvGrpSpPr/>
-        <p:nvPr/>
-      </p:nvGrpSpPr>
-      <p:grpSpPr>
-        <a:xfrm xmlns:a="http://schemas.openxmlformats.org/drawingml/2006/main"/>
-      </p:grpSpPr>
-      <p:sp>
-        <p:nvSpPr>
-          <p:cNvPr id="2" name="Slide Image Placeholder 1"/>
-          <p:cNvSpPr>
-            <a:spLocks xmlns:a="http://schemas.openxmlformats.org/drawingml/2006/main" noGrp="1"/>
-          </p:cNvSpPr>
-          <p:nvPr>
-            <p:ph type="sldImg" idx="0"/>
-          </p:nvPr>
-        </p:nvSpPr>
-        <p:spPr/>
-      </p:sp>
-      <p:sp>
-        <p:nvSpPr>
-          <p:cNvPr id="3" name="Notes Placeholder 2"/>
-          <p:cNvSpPr>
-            <a:spLocks xmlns:a="http://schemas.openxmlformats.org/drawingml/2006/main" noGrp="1"/>
-          </p:cNvSpPr>
-          <p:nvPr>
-            <p:ph type="body" idx="1"/>
-          </p:nvPr>
-        </p:nvSpPr>
-        <p:spPr/>
-        <p:txBody>
-          <a:bodyPr xmlns:a="http://schemas.openxmlformats.org/drawingml/2006/main"/>
-          <a:lstStyle xmlns:a="http://schemas.openxmlformats.org/drawingml/2006/main"/>
-          <a:p xmlns:a="http://schemas.openxmlformats.org/drawingml/2006/main">
-            <a:r>
-              <a:t>Liên kết: https://manhld424.github.io/M38-Edge-PreLabeling/ và https://manhld424.github.io/M38-Edge-PreLabeling/results.html. Nhánh 3D vẫn là thử nghiệm heuristic.</a:t>
-            </a:r>
-          </a:p>
-          <a:p xmlns:a="http://schemas.openxmlformats.org/drawingml/2006/main">
-            <a:r>
-              <a:t>Nguồn: https://manhld424.github.io/M38-Edge-PreLabeling/results.html</a:t>
-            </a:r>
-          </a:p>
-          <a:p xmlns:a="http://schemas.openxmlformats.org/drawingml/2006/main">
-            <a:r>
-              <a:t>https://github.com/ManhLD424/M38-Edge-PreLabeling/tree/51ff2eb</a:t>
-            </a:r>
-          </a:p>
-        </p:txBody>
-      </p:sp>
-      <p:sp>
-        <p:nvSpPr>
-          <p:cNvPr id="4" name="Slide Number Placeholder 3"/>
-          <p:cNvSpPr>
-            <a:spLocks xmlns:a="http://schemas.openxmlformats.org/drawingml/2006/main" noGrp="1"/>
-          </p:cNvSpPr>
-          <p:nvPr>
-            <p:ph type="sldNum" idx="5"/>
-          </p:nvPr>
-        </p:nvSpPr>
-        <p:spPr/>
-        <p:txBody>
-          <a:bodyPr xmlns:a="http://schemas.openxmlformats.org/drawingml/2006/main"/>
-          <a:lstStyle xmlns:a="http://schemas.openxmlformats.org/drawingml/2006/main"/>
-          <a:p xmlns:a="http://schemas.openxmlformats.org/drawingml/2006/main"/>
-        </p:txBody>
-      </p:sp>
-    </p:spTree>
-  </p:cSld>
-  <p:clrMapOvr>
-    <a:masterClrMapping xmlns:a="http://schemas.openxmlformats.org/drawingml/2006/main"/>
-  </p:clrMapOvr>
-</p:notes>
-</file>
-
 <file path=ppt/slideLayouts/slideLayout1.xml><?xml version="1.0" encoding="utf-8"?>
 <p:sldLayout xmlns:p="http://schemas.openxmlformats.org/presentationml/2006/main" type="title">
   <p:cSld name="Title Slide">
@@ -985,7 +904,7 @@
           <p:cNvPr id="3" name="Title">
             <a:extLst xmlns:a="http://schemas.openxmlformats.org/drawingml/2006/main">
               <a:ext uri="{FF2B5EF4-FFF2-40B4-BE49-F238E27FC236}">
-                <a16:creationId xmlns:a16="http://schemas.microsoft.com/office/drawing/2014/main" id="{0319EE12-7944-476C-9582-0744EAF605E3}"/>
+                <a16:creationId xmlns:a16="http://schemas.microsoft.com/office/drawing/2014/main" id="{00FAD992-A80C-4B68-9DAC-05D7945BBDC2}"/>
               </a:ext>
             </a:extLst>
           </p:cNvPr>
@@ -1214,7 +1133,7 @@
           <p:cNvPr id="2" name="Subtitle">
             <a:extLst xmlns:a="http://schemas.openxmlformats.org/drawingml/2006/main">
               <a:ext uri="{FF2B5EF4-FFF2-40B4-BE49-F238E27FC236}">
-                <a16:creationId xmlns:a16="http://schemas.microsoft.com/office/drawing/2014/main" id="{5D710BAB-954A-45E5-A80D-90A70CD78C30}"/>
+                <a16:creationId xmlns:a16="http://schemas.microsoft.com/office/drawing/2014/main" id="{E3969019-381F-41A2-A267-D86EFDA18844}"/>
               </a:ext>
             </a:extLst>
           </p:cNvPr>
@@ -1460,7 +1379,7 @@
           <p:cNvPr id="2" name="Section title">
             <a:extLst xmlns:a="http://schemas.openxmlformats.org/drawingml/2006/main">
               <a:ext uri="{FF2B5EF4-FFF2-40B4-BE49-F238E27FC236}">
-                <a16:creationId xmlns:a16="http://schemas.microsoft.com/office/drawing/2014/main" id="{461D9E44-8DFB-4ACF-A968-A98E3EB458E4}"/>
+                <a16:creationId xmlns:a16="http://schemas.microsoft.com/office/drawing/2014/main" id="{6841F282-74C6-4AF8-B699-A45E17D2E765}"/>
               </a:ext>
             </a:extLst>
           </p:cNvPr>
@@ -1706,7 +1625,7 @@
           <p:cNvPr id="3" name="Title">
             <a:extLst xmlns:a="http://schemas.openxmlformats.org/drawingml/2006/main">
               <a:ext uri="{FF2B5EF4-FFF2-40B4-BE49-F238E27FC236}">
-                <a16:creationId xmlns:a16="http://schemas.microsoft.com/office/drawing/2014/main" id="{7189C1A2-0620-46AE-8B24-D88C53C607C8}"/>
+                <a16:creationId xmlns:a16="http://schemas.microsoft.com/office/drawing/2014/main" id="{463DEEAD-DE94-4A71-83EB-39E8A88C639A}"/>
               </a:ext>
             </a:extLst>
           </p:cNvPr>
@@ -1935,7 +1854,7 @@
           <p:cNvPr id="2" name="Body">
             <a:extLst xmlns:a="http://schemas.openxmlformats.org/drawingml/2006/main">
               <a:ext uri="{FF2B5EF4-FFF2-40B4-BE49-F238E27FC236}">
-                <a16:creationId xmlns:a16="http://schemas.microsoft.com/office/drawing/2014/main" id="{A209E5D4-0644-4123-9923-AF60782BDC41}"/>
+                <a16:creationId xmlns:a16="http://schemas.microsoft.com/office/drawing/2014/main" id="{E56C4DD1-E5FF-4C7B-9B46-DD3A3A0C06FC}"/>
               </a:ext>
             </a:extLst>
           </p:cNvPr>
@@ -2181,7 +2100,7 @@
           <p:cNvPr id="4" name="Title">
             <a:extLst xmlns:a="http://schemas.openxmlformats.org/drawingml/2006/main">
               <a:ext uri="{FF2B5EF4-FFF2-40B4-BE49-F238E27FC236}">
-                <a16:creationId xmlns:a16="http://schemas.microsoft.com/office/drawing/2014/main" id="{3CF621FD-15BF-4DCD-8CCE-61F61D2E1FD7}"/>
+                <a16:creationId xmlns:a16="http://schemas.microsoft.com/office/drawing/2014/main" id="{618A4A87-69FA-4590-AFBE-DA8B84D3E6B0}"/>
               </a:ext>
             </a:extLst>
           </p:cNvPr>
@@ -2410,7 +2329,7 @@
           <p:cNvPr id="2" name="Left column">
             <a:extLst xmlns:a="http://schemas.openxmlformats.org/drawingml/2006/main">
               <a:ext uri="{FF2B5EF4-FFF2-40B4-BE49-F238E27FC236}">
-                <a16:creationId xmlns:a16="http://schemas.microsoft.com/office/drawing/2014/main" id="{66BA5E58-1FCC-4EC4-B04F-3C14C1A132F8}"/>
+                <a16:creationId xmlns:a16="http://schemas.microsoft.com/office/drawing/2014/main" id="{EC5196EB-E156-4A1C-9F8D-291649BBD8E9}"/>
               </a:ext>
             </a:extLst>
           </p:cNvPr>
@@ -2639,7 +2558,7 @@
           <p:cNvPr id="3" name="Right column">
             <a:extLst xmlns:a="http://schemas.openxmlformats.org/drawingml/2006/main">
               <a:ext uri="{FF2B5EF4-FFF2-40B4-BE49-F238E27FC236}">
-                <a16:creationId xmlns:a16="http://schemas.microsoft.com/office/drawing/2014/main" id="{FCDE270D-B335-4CEA-8795-B7E5D22018FF}"/>
+                <a16:creationId xmlns:a16="http://schemas.microsoft.com/office/drawing/2014/main" id="{4D7AA120-79E7-41B8-B598-21662DEF0E0D}"/>
               </a:ext>
             </a:extLst>
           </p:cNvPr>
@@ -2885,7 +2804,7 @@
           <p:cNvPr id="3" name="Title">
             <a:extLst xmlns:a="http://schemas.openxmlformats.org/drawingml/2006/main">
               <a:ext uri="{FF2B5EF4-FFF2-40B4-BE49-F238E27FC236}">
-                <a16:creationId xmlns:a16="http://schemas.microsoft.com/office/drawing/2014/main" id="{3F5CF7E1-3451-4B0B-80EA-09F550296F6E}"/>
+                <a16:creationId xmlns:a16="http://schemas.microsoft.com/office/drawing/2014/main" id="{7F391A07-91B5-4412-A130-6DA8A44E4C8E}"/>
               </a:ext>
             </a:extLst>
           </p:cNvPr>
@@ -3114,7 +3033,7 @@
           <p:cNvPr id="2" name="Left column">
             <a:extLst xmlns:a="http://schemas.openxmlformats.org/drawingml/2006/main">
               <a:ext uri="{FF2B5EF4-FFF2-40B4-BE49-F238E27FC236}">
-                <a16:creationId xmlns:a16="http://schemas.microsoft.com/office/drawing/2014/main" id="{63360696-1231-4593-BEC8-930FB06B9090}"/>
+                <a16:creationId xmlns:a16="http://schemas.microsoft.com/office/drawing/2014/main" id="{09B0FE75-2E81-49ED-96ED-87E6F5A67F9B}"/>
               </a:ext>
             </a:extLst>
           </p:cNvPr>
@@ -3381,12 +3300,12 @@
   </p:cSld>
   <p:clrMap bg1="lt1" tx1="dk1" bg2="lt2" tx2="dk2" accent1="accent1" accent2="accent2" accent3="accent3" accent4="accent4" accent5="accent5" accent6="accent6" hlink="hlink" folHlink="folHlink"/>
   <p:sldLayoutIdLst>
-    <p:sldLayoutId xmlns:r="http://schemas.openxmlformats.org/officeDocument/2006/relationships" id="2147483649" r:id="Rc241b30f61494deb"/>
-    <p:sldLayoutId xmlns:r="http://schemas.openxmlformats.org/officeDocument/2006/relationships" id="2147483650" r:id="Rd79e602520ba47be"/>
-    <p:sldLayoutId xmlns:r="http://schemas.openxmlformats.org/officeDocument/2006/relationships" id="2147483651" r:id="Rb8094e948f7e4d94"/>
-    <p:sldLayoutId xmlns:r="http://schemas.openxmlformats.org/officeDocument/2006/relationships" id="2147483652" r:id="Rbe63596d84d04368"/>
-    <p:sldLayoutId xmlns:r="http://schemas.openxmlformats.org/officeDocument/2006/relationships" id="2147483653" r:id="R720eaac3fcbf4209"/>
-    <p:sldLayoutId xmlns:r="http://schemas.openxmlformats.org/officeDocument/2006/relationships" id="2147483654" r:id="R156fa3fc10d74f80"/>
+    <p:sldLayoutId xmlns:r="http://schemas.openxmlformats.org/officeDocument/2006/relationships" id="2147483649" r:id="Reda6c130016d40f1"/>
+    <p:sldLayoutId xmlns:r="http://schemas.openxmlformats.org/officeDocument/2006/relationships" id="2147483650" r:id="Rb5ebcbc698454ee3"/>
+    <p:sldLayoutId xmlns:r="http://schemas.openxmlformats.org/officeDocument/2006/relationships" id="2147483651" r:id="R8486d91497b54f87"/>
+    <p:sldLayoutId xmlns:r="http://schemas.openxmlformats.org/officeDocument/2006/relationships" id="2147483652" r:id="R84c9d08dde094b17"/>
+    <p:sldLayoutId xmlns:r="http://schemas.openxmlformats.org/officeDocument/2006/relationships" id="2147483653" r:id="R3f9aad64168545bd"/>
+    <p:sldLayoutId xmlns:r="http://schemas.openxmlformats.org/officeDocument/2006/relationships" id="2147483654" r:id="Rfae66b972b954c5f"/>
   </p:sldLayoutIdLst>
   <p:txStyles>
     <p:titleStyle>
@@ -4107,7 +4026,7 @@
           <p:cNvPr id="8" name="">
             <a:extLst xmlns:a="http://schemas.openxmlformats.org/drawingml/2006/main">
               <a:ext uri="{FF2B5EF4-FFF2-40B4-BE49-F238E27FC236}">
-                <a16:creationId xmlns:a16="http://schemas.microsoft.com/office/drawing/2014/main" id="{5ED57428-2990-47BF-96CD-C42ECA3AF06A}"/>
+                <a16:creationId xmlns:a16="http://schemas.microsoft.com/office/drawing/2014/main" id="{3A90693E-57C9-45E4-8E52-91FCB1ACE680}"/>
               </a:ext>
             </a:extLst>
           </p:cNvPr>
@@ -4263,7 +4182,7 @@
           <p:cNvPr id="2" name="">
             <a:extLst xmlns:a="http://schemas.openxmlformats.org/drawingml/2006/main">
               <a:ext uri="{FF2B5EF4-FFF2-40B4-BE49-F238E27FC236}">
-                <a16:creationId xmlns:a16="http://schemas.microsoft.com/office/drawing/2014/main" id="{B08514E3-BF93-4CC9-A7A8-470480F034C0}"/>
+                <a16:creationId xmlns:a16="http://schemas.microsoft.com/office/drawing/2014/main" id="{8EE3D1E2-349A-428E-AD54-DE9FB7E8B0D2}"/>
               </a:ext>
             </a:extLst>
           </p:cNvPr>
@@ -4419,7 +4338,7 @@
           <p:cNvPr id="3" name="">
             <a:extLst xmlns:a="http://schemas.openxmlformats.org/drawingml/2006/main">
               <a:ext uri="{FF2B5EF4-FFF2-40B4-BE49-F238E27FC236}">
-                <a16:creationId xmlns:a16="http://schemas.microsoft.com/office/drawing/2014/main" id="{2642C5B5-DAEB-422D-A03A-B9C84385D4F2}"/>
+                <a16:creationId xmlns:a16="http://schemas.microsoft.com/office/drawing/2014/main" id="{3EB0122A-E0D5-49DF-94D5-A72C54A1B716}"/>
               </a:ext>
             </a:extLst>
           </p:cNvPr>
@@ -4575,7 +4494,7 @@
           <p:cNvPr id="4" name="">
             <a:extLst xmlns:a="http://schemas.openxmlformats.org/drawingml/2006/main">
               <a:ext uri="{FF2B5EF4-FFF2-40B4-BE49-F238E27FC236}">
-                <a16:creationId xmlns:a16="http://schemas.microsoft.com/office/drawing/2014/main" id="{42519EB6-271A-4A96-A14A-67F8801969D7}"/>
+                <a16:creationId xmlns:a16="http://schemas.microsoft.com/office/drawing/2014/main" id="{11ACCFFC-3036-4045-BEFE-1CCFAECAF0A5}"/>
               </a:ext>
             </a:extLst>
           </p:cNvPr>
@@ -4731,7 +4650,7 @@
           <p:cNvPr id="5" name="">
             <a:extLst xmlns:a="http://schemas.openxmlformats.org/drawingml/2006/main">
               <a:ext uri="{FF2B5EF4-FFF2-40B4-BE49-F238E27FC236}">
-                <a16:creationId xmlns:a16="http://schemas.microsoft.com/office/drawing/2014/main" id="{615DB647-714D-4A8A-8164-0500C5A49A4D}"/>
+                <a16:creationId xmlns:a16="http://schemas.microsoft.com/office/drawing/2014/main" id="{1774EDD2-B204-48F8-8AFF-A54B36DE5715}"/>
               </a:ext>
             </a:extLst>
           </p:cNvPr>
@@ -4910,7 +4829,7 @@
           <p:cNvPr id="6" name="">
             <a:extLst xmlns:a="http://schemas.openxmlformats.org/drawingml/2006/main">
               <a:ext uri="{FF2B5EF4-FFF2-40B4-BE49-F238E27FC236}">
-                <a16:creationId xmlns:a16="http://schemas.microsoft.com/office/drawing/2014/main" id="{5E5833C8-D18F-4E83-A864-1514ABFD8526}"/>
+                <a16:creationId xmlns:a16="http://schemas.microsoft.com/office/drawing/2014/main" id="{83E965D4-69BF-4E5A-9750-81FB91DCAEDB}"/>
               </a:ext>
             </a:extLst>
           </p:cNvPr>
@@ -5066,7 +4985,7 @@
           <p:cNvPr id="7" name="">
             <a:extLst xmlns:a="http://schemas.openxmlformats.org/drawingml/2006/main">
               <a:ext uri="{FF2B5EF4-FFF2-40B4-BE49-F238E27FC236}">
-                <a16:creationId xmlns:a16="http://schemas.microsoft.com/office/drawing/2014/main" id="{7AFEBB77-9544-4134-AA6E-DEB807448A01}"/>
+                <a16:creationId xmlns:a16="http://schemas.microsoft.com/office/drawing/2014/main" id="{C7D2DDBF-1729-49FF-8C16-9BA00FFAB4FF}"/>
               </a:ext>
             </a:extLst>
           </p:cNvPr>
@@ -5243,7 +5162,7 @@
     </p:spTree>
     <p:extLst>
       <p:ext uri="{BB962C8B-B14F-4D97-AF65-F5344CB8AC3E}">
-        <p14:creationId xmlns:p14="http://schemas.microsoft.com/office/powerpoint/2010/main" val="1658274767"/>
+        <p14:creationId xmlns:p14="http://schemas.microsoft.com/office/powerpoint/2010/main" val="1014411904"/>
       </p:ext>
     </p:extLst>
   </p:cSld>
@@ -5274,7 +5193,7 @@
           <p:cNvPr id="10" name="">
             <a:extLst xmlns:a="http://schemas.openxmlformats.org/drawingml/2006/main">
               <a:ext uri="{FF2B5EF4-FFF2-40B4-BE49-F238E27FC236}">
-                <a16:creationId xmlns:a16="http://schemas.microsoft.com/office/drawing/2014/main" id="{67CEC0CC-E133-4A63-84E2-19D885207C59}"/>
+                <a16:creationId xmlns:a16="http://schemas.microsoft.com/office/drawing/2014/main" id="{8FA8C0E9-47D4-43F0-BE4A-F1B817896773}"/>
               </a:ext>
             </a:extLst>
           </p:cNvPr>
@@ -5430,7 +5349,7 @@
           <p:cNvPr id="2" name="">
             <a:extLst xmlns:a="http://schemas.openxmlformats.org/drawingml/2006/main">
               <a:ext uri="{FF2B5EF4-FFF2-40B4-BE49-F238E27FC236}">
-                <a16:creationId xmlns:a16="http://schemas.microsoft.com/office/drawing/2014/main" id="{3DE9AB94-ABA7-4A6A-B75F-70EA83D4F09A}"/>
+                <a16:creationId xmlns:a16="http://schemas.microsoft.com/office/drawing/2014/main" id="{21838347-DCB8-4DE2-BC22-76627A7F0FB9}"/>
               </a:ext>
             </a:extLst>
           </p:cNvPr>
@@ -5586,7 +5505,7 @@
           <p:cNvPr id="3" name="">
             <a:extLst xmlns:a="http://schemas.openxmlformats.org/drawingml/2006/main">
               <a:ext uri="{FF2B5EF4-FFF2-40B4-BE49-F238E27FC236}">
-                <a16:creationId xmlns:a16="http://schemas.microsoft.com/office/drawing/2014/main" id="{26F6118A-74EF-4427-B07C-74A73E1BD9D7}"/>
+                <a16:creationId xmlns:a16="http://schemas.microsoft.com/office/drawing/2014/main" id="{662CE700-81F2-4719-B059-36AAB8250211}"/>
               </a:ext>
             </a:extLst>
           </p:cNvPr>
@@ -5742,7 +5661,7 @@
           <p:cNvPr id="4" name="">
             <a:extLst xmlns:a="http://schemas.openxmlformats.org/drawingml/2006/main">
               <a:ext uri="{FF2B5EF4-FFF2-40B4-BE49-F238E27FC236}">
-                <a16:creationId xmlns:a16="http://schemas.microsoft.com/office/drawing/2014/main" id="{83690747-B2E9-4FAB-B9B2-125B5DE86C93}"/>
+                <a16:creationId xmlns:a16="http://schemas.microsoft.com/office/drawing/2014/main" id="{B8D58FF9-EA83-4A2D-AE34-B1DE840722DE}"/>
               </a:ext>
             </a:extLst>
           </p:cNvPr>
@@ -5898,7 +5817,7 @@
           <p:cNvPr id="5" name="">
             <a:extLst xmlns:a="http://schemas.openxmlformats.org/drawingml/2006/main">
               <a:ext uri="{FF2B5EF4-FFF2-40B4-BE49-F238E27FC236}">
-                <a16:creationId xmlns:a16="http://schemas.microsoft.com/office/drawing/2014/main" id="{888EB100-58B7-485F-8451-AD90C905E760}"/>
+                <a16:creationId xmlns:a16="http://schemas.microsoft.com/office/drawing/2014/main" id="{B44B5FD8-7859-4F05-AB06-360EC6387AF8}"/>
               </a:ext>
             </a:extLst>
           </p:cNvPr>
@@ -6054,7 +5973,7 @@
           <p:cNvPr id="6" name="">
             <a:extLst xmlns:a="http://schemas.openxmlformats.org/drawingml/2006/main">
               <a:ext uri="{FF2B5EF4-FFF2-40B4-BE49-F238E27FC236}">
-                <a16:creationId xmlns:a16="http://schemas.microsoft.com/office/drawing/2014/main" id="{331C1F92-D463-4D07-929D-9E934346BB00}"/>
+                <a16:creationId xmlns:a16="http://schemas.microsoft.com/office/drawing/2014/main" id="{888A8414-847B-402B-98F9-E33C364DFD1E}"/>
               </a:ext>
             </a:extLst>
           </p:cNvPr>
@@ -6233,7 +6152,7 @@
           <p:cNvPr id="7" name="">
             <a:extLst xmlns:a="http://schemas.openxmlformats.org/drawingml/2006/main">
               <a:ext uri="{FF2B5EF4-FFF2-40B4-BE49-F238E27FC236}">
-                <a16:creationId xmlns:a16="http://schemas.microsoft.com/office/drawing/2014/main" id="{C375B73B-60EC-4750-9FF1-7F054BF6E922}"/>
+                <a16:creationId xmlns:a16="http://schemas.microsoft.com/office/drawing/2014/main" id="{359F4673-FB56-4932-BC73-1D9954D861ED}"/>
               </a:ext>
             </a:extLst>
           </p:cNvPr>
@@ -6389,7 +6308,7 @@
           <p:cNvPr id="8" name="">
             <a:extLst xmlns:a="http://schemas.openxmlformats.org/drawingml/2006/main">
               <a:ext uri="{FF2B5EF4-FFF2-40B4-BE49-F238E27FC236}">
-                <a16:creationId xmlns:a16="http://schemas.microsoft.com/office/drawing/2014/main" id="{6DBF82DB-10A3-4956-B374-35A9A265686A}"/>
+                <a16:creationId xmlns:a16="http://schemas.microsoft.com/office/drawing/2014/main" id="{5CDC36C8-65BE-427C-A1FE-62C3C279ADA9}"/>
               </a:ext>
             </a:extLst>
           </p:cNvPr>
@@ -6591,7 +6510,7 @@
           <p:cNvPr id="9" name="">
             <a:extLst xmlns:a="http://schemas.openxmlformats.org/drawingml/2006/main">
               <a:ext uri="{FF2B5EF4-FFF2-40B4-BE49-F238E27FC236}">
-                <a16:creationId xmlns:a16="http://schemas.microsoft.com/office/drawing/2014/main" id="{A476AB9B-B4D5-4463-A604-2AAA9349D154}"/>
+                <a16:creationId xmlns:a16="http://schemas.microsoft.com/office/drawing/2014/main" id="{90F8DFF8-D457-4941-8AF2-C4408BFB7784}"/>
               </a:ext>
             </a:extLst>
           </p:cNvPr>
@@ -6768,7 +6687,7 @@
     </p:spTree>
     <p:extLst>
       <p:ext uri="{BB962C8B-B14F-4D97-AF65-F5344CB8AC3E}">
-        <p14:creationId xmlns:p14="http://schemas.microsoft.com/office/powerpoint/2010/main" val="1480488965"/>
+        <p14:creationId xmlns:p14="http://schemas.microsoft.com/office/powerpoint/2010/main" val="1002174001"/>
       </p:ext>
     </p:extLst>
   </p:cSld>
@@ -6799,7 +6718,7 @@
           <p:cNvPr id="7" name="">
             <a:extLst xmlns:a="http://schemas.openxmlformats.org/drawingml/2006/main">
               <a:ext uri="{FF2B5EF4-FFF2-40B4-BE49-F238E27FC236}">
-                <a16:creationId xmlns:a16="http://schemas.microsoft.com/office/drawing/2014/main" id="{957487A2-212C-44C3-9920-9F13B33ECD40}"/>
+                <a16:creationId xmlns:a16="http://schemas.microsoft.com/office/drawing/2014/main" id="{B0BDF56E-C025-4CD1-89AD-9A961ECE9CC1}"/>
               </a:ext>
             </a:extLst>
           </p:cNvPr>
@@ -6955,7 +6874,7 @@
           <p:cNvPr id="2" name="">
             <a:extLst xmlns:a="http://schemas.openxmlformats.org/drawingml/2006/main">
               <a:ext uri="{FF2B5EF4-FFF2-40B4-BE49-F238E27FC236}">
-                <a16:creationId xmlns:a16="http://schemas.microsoft.com/office/drawing/2014/main" id="{CCF6117F-906A-4095-B8D8-915CB7004A92}"/>
+                <a16:creationId xmlns:a16="http://schemas.microsoft.com/office/drawing/2014/main" id="{F32FCCF8-779A-4698-BD69-049A9F4D8F1C}"/>
               </a:ext>
             </a:extLst>
           </p:cNvPr>
@@ -7111,7 +7030,7 @@
           <p:cNvPr id="3" name="">
             <a:extLst xmlns:a="http://schemas.openxmlformats.org/drawingml/2006/main">
               <a:ext uri="{FF2B5EF4-FFF2-40B4-BE49-F238E27FC236}">
-                <a16:creationId xmlns:a16="http://schemas.microsoft.com/office/drawing/2014/main" id="{73B59528-A1D8-4E19-8404-E9F52BEE56A6}"/>
+                <a16:creationId xmlns:a16="http://schemas.microsoft.com/office/drawing/2014/main" id="{5A8587E0-B118-425D-A33F-5D59860433BD}"/>
               </a:ext>
             </a:extLst>
           </p:cNvPr>
@@ -7267,7 +7186,7 @@
           <p:cNvPr id="4" name="">
             <a:extLst xmlns:a="http://schemas.openxmlformats.org/drawingml/2006/main">
               <a:ext uri="{FF2B5EF4-FFF2-40B4-BE49-F238E27FC236}">
-                <a16:creationId xmlns:a16="http://schemas.microsoft.com/office/drawing/2014/main" id="{24C649C9-03AC-447A-88BD-2D2841843EAE}"/>
+                <a16:creationId xmlns:a16="http://schemas.microsoft.com/office/drawing/2014/main" id="{FC9BE08E-9522-4EF8-BA21-48F105FE83F0}"/>
               </a:ext>
             </a:extLst>
           </p:cNvPr>
@@ -7423,7 +7342,7 @@
           <p:cNvPr id="5" name="">
             <a:extLst xmlns:a="http://schemas.openxmlformats.org/drawingml/2006/main">
               <a:ext uri="{FF2B5EF4-FFF2-40B4-BE49-F238E27FC236}">
-                <a16:creationId xmlns:a16="http://schemas.microsoft.com/office/drawing/2014/main" id="{4FDE9392-B887-4142-A7EB-B05F7E8B13E2}"/>
+                <a16:creationId xmlns:a16="http://schemas.microsoft.com/office/drawing/2014/main" id="{086D57F5-3D9A-4790-A6F4-E9B3041264AC}"/>
               </a:ext>
             </a:extLst>
           </p:cNvPr>
@@ -7433,7 +7352,7 @@
           <p:nvPr/>
         </p:nvPicPr>
         <p:blipFill>
-          <a:blip xmlns:r="http://schemas.openxmlformats.org/officeDocument/2006/relationships" xmlns:a="http://schemas.openxmlformats.org/drawingml/2006/main" r:embed="R60d89a7416ad4959"/>
+          <a:blip xmlns:r="http://schemas.openxmlformats.org/officeDocument/2006/relationships" xmlns:a="http://schemas.openxmlformats.org/drawingml/2006/main" r:embed="Re119697c26e04f05"/>
           <a:stretch xmlns:a="http://schemas.openxmlformats.org/drawingml/2006/main"/>
         </p:blipFill>
         <p:spPr>
@@ -7451,7 +7370,7 @@
           <p:cNvPr id="6" name="">
             <a:extLst xmlns:a="http://schemas.openxmlformats.org/drawingml/2006/main">
               <a:ext uri="{FF2B5EF4-FFF2-40B4-BE49-F238E27FC236}">
-                <a16:creationId xmlns:a16="http://schemas.microsoft.com/office/drawing/2014/main" id="{75F611FF-F638-4317-9E7E-945FD67731C0}"/>
+                <a16:creationId xmlns:a16="http://schemas.microsoft.com/office/drawing/2014/main" id="{BE784A29-0AA5-4671-BB8F-5555A6E41F37}"/>
               </a:ext>
             </a:extLst>
           </p:cNvPr>
@@ -7689,7 +7608,7 @@
     </p:spTree>
     <p:extLst>
       <p:ext uri="{BB962C8B-B14F-4D97-AF65-F5344CB8AC3E}">
-        <p14:creationId xmlns:p14="http://schemas.microsoft.com/office/powerpoint/2010/main" val="408517957"/>
+        <p14:creationId xmlns:p14="http://schemas.microsoft.com/office/powerpoint/2010/main" val="1626627021"/>
       </p:ext>
     </p:extLst>
   </p:cSld>
@@ -7720,7 +7639,7 @@
           <p:cNvPr id="11" name="">
             <a:extLst xmlns:a="http://schemas.openxmlformats.org/drawingml/2006/main">
               <a:ext uri="{FF2B5EF4-FFF2-40B4-BE49-F238E27FC236}">
-                <a16:creationId xmlns:a16="http://schemas.microsoft.com/office/drawing/2014/main" id="{34638D47-CA6E-494B-B0A7-671F99A6029A}"/>
+                <a16:creationId xmlns:a16="http://schemas.microsoft.com/office/drawing/2014/main" id="{0783DC87-9C18-49FE-A1E1-CCC2D7F46725}"/>
               </a:ext>
             </a:extLst>
           </p:cNvPr>
@@ -7876,7 +7795,7 @@
           <p:cNvPr id="2" name="">
             <a:extLst xmlns:a="http://schemas.openxmlformats.org/drawingml/2006/main">
               <a:ext uri="{FF2B5EF4-FFF2-40B4-BE49-F238E27FC236}">
-                <a16:creationId xmlns:a16="http://schemas.microsoft.com/office/drawing/2014/main" id="{3B6DBADA-A113-49AC-8275-B5F85724E737}"/>
+                <a16:creationId xmlns:a16="http://schemas.microsoft.com/office/drawing/2014/main" id="{7022E1FA-C9FC-4599-AA7A-7E205439CFA5}"/>
               </a:ext>
             </a:extLst>
           </p:cNvPr>
@@ -8032,7 +7951,7 @@
           <p:cNvPr id="3" name="">
             <a:extLst xmlns:a="http://schemas.openxmlformats.org/drawingml/2006/main">
               <a:ext uri="{FF2B5EF4-FFF2-40B4-BE49-F238E27FC236}">
-                <a16:creationId xmlns:a16="http://schemas.microsoft.com/office/drawing/2014/main" id="{77C9F0F8-CDE2-48DA-A77C-BA2A461252AF}"/>
+                <a16:creationId xmlns:a16="http://schemas.microsoft.com/office/drawing/2014/main" id="{0F3D76B6-2BB7-4D39-9CA3-EF2F4D1DC63D}"/>
               </a:ext>
             </a:extLst>
           </p:cNvPr>
@@ -8188,7 +8107,7 @@
           <p:cNvPr id="4" name="">
             <a:extLst xmlns:a="http://schemas.openxmlformats.org/drawingml/2006/main">
               <a:ext uri="{FF2B5EF4-FFF2-40B4-BE49-F238E27FC236}">
-                <a16:creationId xmlns:a16="http://schemas.microsoft.com/office/drawing/2014/main" id="{6F096367-3178-4327-84C3-9B0BC92C2AEA}"/>
+                <a16:creationId xmlns:a16="http://schemas.microsoft.com/office/drawing/2014/main" id="{C7CBFE9C-8739-4DE8-ABE8-5336C059DAB5}"/>
               </a:ext>
             </a:extLst>
           </p:cNvPr>
@@ -8344,7 +8263,7 @@
           <p:cNvPr id="5" name="">
             <a:extLst xmlns:a="http://schemas.openxmlformats.org/drawingml/2006/main">
               <a:ext uri="{FF2B5EF4-FFF2-40B4-BE49-F238E27FC236}">
-                <a16:creationId xmlns:a16="http://schemas.microsoft.com/office/drawing/2014/main" id="{64EDAC82-9678-460F-B759-BFEAB19058D9}"/>
+                <a16:creationId xmlns:a16="http://schemas.microsoft.com/office/drawing/2014/main" id="{D52FC79A-36AB-4F70-BD38-638DEFBF98C0}"/>
               </a:ext>
             </a:extLst>
           </p:cNvPr>
@@ -8500,7 +8419,7 @@
           <p:cNvPr id="6" name="">
             <a:extLst xmlns:a="http://schemas.openxmlformats.org/drawingml/2006/main">
               <a:ext uri="{FF2B5EF4-FFF2-40B4-BE49-F238E27FC236}">
-                <a16:creationId xmlns:a16="http://schemas.microsoft.com/office/drawing/2014/main" id="{8A888116-8FA5-40F5-9479-6DF01C7BC34A}"/>
+                <a16:creationId xmlns:a16="http://schemas.microsoft.com/office/drawing/2014/main" id="{32F31734-B623-41AD-8D54-0AF0582E1A73}"/>
               </a:ext>
             </a:extLst>
           </p:cNvPr>
@@ -8656,7 +8575,7 @@
           <p:cNvPr id="7" name="">
             <a:extLst xmlns:a="http://schemas.openxmlformats.org/drawingml/2006/main">
               <a:ext uri="{FF2B5EF4-FFF2-40B4-BE49-F238E27FC236}">
-                <a16:creationId xmlns:a16="http://schemas.microsoft.com/office/drawing/2014/main" id="{D5E92491-D47F-4D97-9C78-49C2A4CBCA53}"/>
+                <a16:creationId xmlns:a16="http://schemas.microsoft.com/office/drawing/2014/main" id="{8AD0C0C6-680C-4275-B8BD-729B182A69DD}"/>
               </a:ext>
             </a:extLst>
           </p:cNvPr>
@@ -8812,7 +8731,7 @@
           <p:cNvPr id="8" name="">
             <a:extLst xmlns:a="http://schemas.openxmlformats.org/drawingml/2006/main">
               <a:ext uri="{FF2B5EF4-FFF2-40B4-BE49-F238E27FC236}">
-                <a16:creationId xmlns:a16="http://schemas.microsoft.com/office/drawing/2014/main" id="{C5A94807-07A3-46E9-B327-43612A147082}"/>
+                <a16:creationId xmlns:a16="http://schemas.microsoft.com/office/drawing/2014/main" id="{3058D61E-8DA4-4D57-B9DD-AAFFA7008977}"/>
               </a:ext>
             </a:extLst>
           </p:cNvPr>
@@ -8968,7 +8887,7 @@
           <p:cNvPr id="9" name="">
             <a:extLst xmlns:a="http://schemas.openxmlformats.org/drawingml/2006/main">
               <a:ext uri="{FF2B5EF4-FFF2-40B4-BE49-F238E27FC236}">
-                <a16:creationId xmlns:a16="http://schemas.microsoft.com/office/drawing/2014/main" id="{41436DA5-61E4-4B43-B295-6986F6B8F1B0}"/>
+                <a16:creationId xmlns:a16="http://schemas.microsoft.com/office/drawing/2014/main" id="{C0225E6A-6D11-41E0-BE28-C2321D950D0B}"/>
               </a:ext>
             </a:extLst>
           </p:cNvPr>
@@ -9124,7 +9043,7 @@
           <p:cNvPr id="10" name="">
             <a:extLst xmlns:a="http://schemas.openxmlformats.org/drawingml/2006/main">
               <a:ext uri="{FF2B5EF4-FFF2-40B4-BE49-F238E27FC236}">
-                <a16:creationId xmlns:a16="http://schemas.microsoft.com/office/drawing/2014/main" id="{C63774BF-C12D-4579-9315-40150FD60B9F}"/>
+                <a16:creationId xmlns:a16="http://schemas.microsoft.com/office/drawing/2014/main" id="{CB2071F6-85EE-4428-9EB6-65164D96B8AA}"/>
               </a:ext>
             </a:extLst>
           </p:cNvPr>
@@ -9278,7 +9197,7 @@
     </p:spTree>
     <p:extLst>
       <p:ext uri="{BB962C8B-B14F-4D97-AF65-F5344CB8AC3E}">
-        <p14:creationId xmlns:p14="http://schemas.microsoft.com/office/powerpoint/2010/main" val="1877884510"/>
+        <p14:creationId xmlns:p14="http://schemas.microsoft.com/office/powerpoint/2010/main" val="931467737"/>
       </p:ext>
     </p:extLst>
   </p:cSld>
@@ -9309,7 +9228,7 @@
           <p:cNvPr id="10" name="">
             <a:extLst xmlns:a="http://schemas.openxmlformats.org/drawingml/2006/main">
               <a:ext uri="{FF2B5EF4-FFF2-40B4-BE49-F238E27FC236}">
-                <a16:creationId xmlns:a16="http://schemas.microsoft.com/office/drawing/2014/main" id="{7A3E2CE0-0F4E-45EA-88BD-FFB81978A849}"/>
+                <a16:creationId xmlns:a16="http://schemas.microsoft.com/office/drawing/2014/main" id="{5C2E8A69-B8BD-42C4-9D81-EC44412BC140}"/>
               </a:ext>
             </a:extLst>
           </p:cNvPr>
@@ -9465,7 +9384,7 @@
           <p:cNvPr id="2" name="">
             <a:extLst xmlns:a="http://schemas.openxmlformats.org/drawingml/2006/main">
               <a:ext uri="{FF2B5EF4-FFF2-40B4-BE49-F238E27FC236}">
-                <a16:creationId xmlns:a16="http://schemas.microsoft.com/office/drawing/2014/main" id="{7C94848C-AA4E-4EF8-98EC-DC7A46BCF824}"/>
+                <a16:creationId xmlns:a16="http://schemas.microsoft.com/office/drawing/2014/main" id="{0BDFDBFA-7466-4F3D-BF94-33E2CF0386D8}"/>
               </a:ext>
             </a:extLst>
           </p:cNvPr>
@@ -9621,7 +9540,7 @@
           <p:cNvPr id="3" name="">
             <a:extLst xmlns:a="http://schemas.openxmlformats.org/drawingml/2006/main">
               <a:ext uri="{FF2B5EF4-FFF2-40B4-BE49-F238E27FC236}">
-                <a16:creationId xmlns:a16="http://schemas.microsoft.com/office/drawing/2014/main" id="{38397197-F2D7-4C46-9C6E-E0A7C802F219}"/>
+                <a16:creationId xmlns:a16="http://schemas.microsoft.com/office/drawing/2014/main" id="{55E270C0-1C22-4F0F-AB5C-57826DCA7AC3}"/>
               </a:ext>
             </a:extLst>
           </p:cNvPr>
@@ -9777,7 +9696,7 @@
           <p:cNvPr id="4" name="">
             <a:extLst xmlns:a="http://schemas.openxmlformats.org/drawingml/2006/main">
               <a:ext uri="{FF2B5EF4-FFF2-40B4-BE49-F238E27FC236}">
-                <a16:creationId xmlns:a16="http://schemas.microsoft.com/office/drawing/2014/main" id="{F7D14571-3267-464E-9BE6-EF64FC4EF2B1}"/>
+                <a16:creationId xmlns:a16="http://schemas.microsoft.com/office/drawing/2014/main" id="{F064BBCA-6816-4EFE-BA38-BA23C112DFD2}"/>
               </a:ext>
             </a:extLst>
           </p:cNvPr>
@@ -9933,7 +9852,7 @@
           <p:cNvPr id="5" name="Chart">
             <a:extLst xmlns:a="http://schemas.openxmlformats.org/drawingml/2006/main">
               <a:ext uri="{FF2B5EF4-FFF2-40B4-BE49-F238E27FC236}">
-                <a16:creationId xmlns:a16="http://schemas.microsoft.com/office/drawing/2014/main" id="{0DDD40F5-F33F-4CBF-91A4-1B8B82989CA3}"/>
+                <a16:creationId xmlns:a16="http://schemas.microsoft.com/office/drawing/2014/main" id="{28E8CD0F-136C-4BAB-83B2-169600AC4F95}"/>
               </a:ext>
             </a:extLst>
           </p:cNvPr>
@@ -9946,7 +9865,7 @@
         </p:xfrm>
         <a:graphic xmlns:a="http://schemas.openxmlformats.org/drawingml/2006/main">
           <a:graphicData uri="http://schemas.openxmlformats.org/drawingml/2006/chart">
-            <c:chart xmlns:r="http://schemas.openxmlformats.org/officeDocument/2006/relationships" xmlns:c="http://schemas.openxmlformats.org/drawingml/2006/chart" r:id="Rcbdd1bc306d348f8"/>
+            <c:chart xmlns:r="http://schemas.openxmlformats.org/officeDocument/2006/relationships" xmlns:c="http://schemas.openxmlformats.org/drawingml/2006/chart" r:id="R2f520f70745c4099"/>
           </a:graphicData>
         </a:graphic>
       </p:graphicFrame>
@@ -9955,7 +9874,7 @@
           <p:cNvPr id="6" name="">
             <a:extLst xmlns:a="http://schemas.openxmlformats.org/drawingml/2006/main">
               <a:ext uri="{FF2B5EF4-FFF2-40B4-BE49-F238E27FC236}">
-                <a16:creationId xmlns:a16="http://schemas.microsoft.com/office/drawing/2014/main" id="{0D483903-CBC6-43F0-AFB4-D7DD4D5BEE8A}"/>
+                <a16:creationId xmlns:a16="http://schemas.microsoft.com/office/drawing/2014/main" id="{C67895FD-C2BD-463E-8C1E-9F9B45A97EE5}"/>
               </a:ext>
             </a:extLst>
           </p:cNvPr>
@@ -10111,7 +10030,7 @@
           <p:cNvPr id="7" name="">
             <a:extLst xmlns:a="http://schemas.openxmlformats.org/drawingml/2006/main">
               <a:ext uri="{FF2B5EF4-FFF2-40B4-BE49-F238E27FC236}">
-                <a16:creationId xmlns:a16="http://schemas.microsoft.com/office/drawing/2014/main" id="{1BF50137-46DA-481D-8ACF-6D6A47160E83}"/>
+                <a16:creationId xmlns:a16="http://schemas.microsoft.com/office/drawing/2014/main" id="{EF49AC4B-439F-4E4B-B40D-CB8B80D5DB09}"/>
               </a:ext>
             </a:extLst>
           </p:cNvPr>
@@ -10290,7 +10209,7 @@
           <p:cNvPr id="8" name="">
             <a:extLst xmlns:a="http://schemas.openxmlformats.org/drawingml/2006/main">
               <a:ext uri="{FF2B5EF4-FFF2-40B4-BE49-F238E27FC236}">
-                <a16:creationId xmlns:a16="http://schemas.microsoft.com/office/drawing/2014/main" id="{44A3B5A7-65DA-47EF-BD86-F02EF80C36EA}"/>
+                <a16:creationId xmlns:a16="http://schemas.microsoft.com/office/drawing/2014/main" id="{A86641E6-24EC-4237-9143-9A9EE3B819BA}"/>
               </a:ext>
             </a:extLst>
           </p:cNvPr>
@@ -10469,7 +10388,7 @@
           <p:cNvPr id="9" name="">
             <a:extLst xmlns:a="http://schemas.openxmlformats.org/drawingml/2006/main">
               <a:ext uri="{FF2B5EF4-FFF2-40B4-BE49-F238E27FC236}">
-                <a16:creationId xmlns:a16="http://schemas.microsoft.com/office/drawing/2014/main" id="{08358F10-8095-49FA-883F-B77ED84B2C01}"/>
+                <a16:creationId xmlns:a16="http://schemas.microsoft.com/office/drawing/2014/main" id="{DCFD8097-6718-4107-A78C-C613454AB008}"/>
               </a:ext>
             </a:extLst>
           </p:cNvPr>
@@ -10646,7 +10565,7 @@
     </p:spTree>
     <p:extLst>
       <p:ext uri="{BB962C8B-B14F-4D97-AF65-F5344CB8AC3E}">
-        <p14:creationId xmlns:p14="http://schemas.microsoft.com/office/powerpoint/2010/main" val="1439435076"/>
+        <p14:creationId xmlns:p14="http://schemas.microsoft.com/office/powerpoint/2010/main" val="1254778426"/>
       </p:ext>
     </p:extLst>
   </p:cSld>
@@ -10677,7 +10596,7 @@
           <p:cNvPr id="19" name="">
             <a:extLst xmlns:a="http://schemas.openxmlformats.org/drawingml/2006/main">
               <a:ext uri="{FF2B5EF4-FFF2-40B4-BE49-F238E27FC236}">
-                <a16:creationId xmlns:a16="http://schemas.microsoft.com/office/drawing/2014/main" id="{D00FB685-1912-4234-8203-D00826A0723B}"/>
+                <a16:creationId xmlns:a16="http://schemas.microsoft.com/office/drawing/2014/main" id="{2ED5402C-22B8-478B-A1CA-94FDA010A586}"/>
               </a:ext>
             </a:extLst>
           </p:cNvPr>
@@ -10833,7 +10752,7 @@
           <p:cNvPr id="2" name="">
             <a:extLst xmlns:a="http://schemas.openxmlformats.org/drawingml/2006/main">
               <a:ext uri="{FF2B5EF4-FFF2-40B4-BE49-F238E27FC236}">
-                <a16:creationId xmlns:a16="http://schemas.microsoft.com/office/drawing/2014/main" id="{B15B999E-DBBD-493A-8481-4D46DBB2B0A4}"/>
+                <a16:creationId xmlns:a16="http://schemas.microsoft.com/office/drawing/2014/main" id="{167A5572-04E4-43DB-87BE-30D935CFD588}"/>
               </a:ext>
             </a:extLst>
           </p:cNvPr>
@@ -10989,7 +10908,7 @@
           <p:cNvPr id="3" name="">
             <a:extLst xmlns:a="http://schemas.openxmlformats.org/drawingml/2006/main">
               <a:ext uri="{FF2B5EF4-FFF2-40B4-BE49-F238E27FC236}">
-                <a16:creationId xmlns:a16="http://schemas.microsoft.com/office/drawing/2014/main" id="{FD88D0C4-6176-471A-B35A-629DF59D0047}"/>
+                <a16:creationId xmlns:a16="http://schemas.microsoft.com/office/drawing/2014/main" id="{2D4E696C-D105-4DB6-B4B6-06167AC9C78B}"/>
               </a:ext>
             </a:extLst>
           </p:cNvPr>
@@ -11145,7 +11064,7 @@
           <p:cNvPr id="4" name="">
             <a:extLst xmlns:a="http://schemas.openxmlformats.org/drawingml/2006/main">
               <a:ext uri="{FF2B5EF4-FFF2-40B4-BE49-F238E27FC236}">
-                <a16:creationId xmlns:a16="http://schemas.microsoft.com/office/drawing/2014/main" id="{96AC22E3-7418-4E44-ADA7-B8619CC099CA}"/>
+                <a16:creationId xmlns:a16="http://schemas.microsoft.com/office/drawing/2014/main" id="{CF48B663-973E-4DBF-9899-9787594465CD}"/>
               </a:ext>
             </a:extLst>
           </p:cNvPr>
@@ -11301,7 +11220,7 @@
           <p:cNvPr id="5" name="">
             <a:extLst xmlns:a="http://schemas.openxmlformats.org/drawingml/2006/main">
               <a:ext uri="{FF2B5EF4-FFF2-40B4-BE49-F238E27FC236}">
-                <a16:creationId xmlns:a16="http://schemas.microsoft.com/office/drawing/2014/main" id="{EB0E2FD0-D9CB-404F-A891-0FCAF080FBB0}"/>
+                <a16:creationId xmlns:a16="http://schemas.microsoft.com/office/drawing/2014/main" id="{4018E160-9B18-43E9-89F0-673430BAC63C}"/>
               </a:ext>
             </a:extLst>
           </p:cNvPr>
@@ -11457,7 +11376,7 @@
           <p:cNvPr id="6" name="">
             <a:extLst xmlns:a="http://schemas.openxmlformats.org/drawingml/2006/main">
               <a:ext uri="{FF2B5EF4-FFF2-40B4-BE49-F238E27FC236}">
-                <a16:creationId xmlns:a16="http://schemas.microsoft.com/office/drawing/2014/main" id="{46E000BE-D9F7-46F9-B435-085768372CC4}"/>
+                <a16:creationId xmlns:a16="http://schemas.microsoft.com/office/drawing/2014/main" id="{6EF32120-6522-4448-8CF1-AAD8945BA0E3}"/>
               </a:ext>
             </a:extLst>
           </p:cNvPr>
@@ -11613,7 +11532,7 @@
           <p:cNvPr id="7" name="">
             <a:extLst xmlns:a="http://schemas.openxmlformats.org/drawingml/2006/main">
               <a:ext uri="{FF2B5EF4-FFF2-40B4-BE49-F238E27FC236}">
-                <a16:creationId xmlns:a16="http://schemas.microsoft.com/office/drawing/2014/main" id="{B81E935F-ED2F-4E40-8748-517ECE99E754}"/>
+                <a16:creationId xmlns:a16="http://schemas.microsoft.com/office/drawing/2014/main" id="{2C469436-986F-45AE-97F4-330FA182A749}"/>
               </a:ext>
             </a:extLst>
           </p:cNvPr>
@@ -11769,7 +11688,7 @@
           <p:cNvPr id="8" name="">
             <a:extLst xmlns:a="http://schemas.openxmlformats.org/drawingml/2006/main">
               <a:ext uri="{FF2B5EF4-FFF2-40B4-BE49-F238E27FC236}">
-                <a16:creationId xmlns:a16="http://schemas.microsoft.com/office/drawing/2014/main" id="{199C034E-078D-4236-AAA4-F86930C9E221}"/>
+                <a16:creationId xmlns:a16="http://schemas.microsoft.com/office/drawing/2014/main" id="{99687870-2C65-410D-B8BB-4415BEC40E31}"/>
               </a:ext>
             </a:extLst>
           </p:cNvPr>
@@ -11925,7 +11844,7 @@
           <p:cNvPr id="9" name="">
             <a:extLst xmlns:a="http://schemas.openxmlformats.org/drawingml/2006/main">
               <a:ext uri="{FF2B5EF4-FFF2-40B4-BE49-F238E27FC236}">
-                <a16:creationId xmlns:a16="http://schemas.microsoft.com/office/drawing/2014/main" id="{74120F63-2932-4B88-B59D-A6939D1716B8}"/>
+                <a16:creationId xmlns:a16="http://schemas.microsoft.com/office/drawing/2014/main" id="{4ADB7097-5CC2-4AC5-8ED8-EA067E4969DE}"/>
               </a:ext>
             </a:extLst>
           </p:cNvPr>
@@ -12081,7 +12000,7 @@
           <p:cNvPr id="10" name="">
             <a:extLst xmlns:a="http://schemas.openxmlformats.org/drawingml/2006/main">
               <a:ext uri="{FF2B5EF4-FFF2-40B4-BE49-F238E27FC236}">
-                <a16:creationId xmlns:a16="http://schemas.microsoft.com/office/drawing/2014/main" id="{6A94B851-5914-40A9-BDDE-1CBEF36CF55C}"/>
+                <a16:creationId xmlns:a16="http://schemas.microsoft.com/office/drawing/2014/main" id="{87CE74E1-2A13-47F8-8257-E235E7CCAC34}"/>
               </a:ext>
             </a:extLst>
           </p:cNvPr>
@@ -12237,7 +12156,7 @@
           <p:cNvPr id="11" name="">
             <a:extLst xmlns:a="http://schemas.openxmlformats.org/drawingml/2006/main">
               <a:ext uri="{FF2B5EF4-FFF2-40B4-BE49-F238E27FC236}">
-                <a16:creationId xmlns:a16="http://schemas.microsoft.com/office/drawing/2014/main" id="{DD4E899D-1860-49E3-8C39-B8A84DB7A7AA}"/>
+                <a16:creationId xmlns:a16="http://schemas.microsoft.com/office/drawing/2014/main" id="{AC62D39F-D0D0-483D-B894-2DEF49BE47AB}"/>
               </a:ext>
             </a:extLst>
           </p:cNvPr>
@@ -12393,7 +12312,7 @@
           <p:cNvPr id="12" name="">
             <a:extLst xmlns:a="http://schemas.openxmlformats.org/drawingml/2006/main">
               <a:ext uri="{FF2B5EF4-FFF2-40B4-BE49-F238E27FC236}">
-                <a16:creationId xmlns:a16="http://schemas.microsoft.com/office/drawing/2014/main" id="{DD9702F6-F707-465D-BAFD-AC61D8EEF2B9}"/>
+                <a16:creationId xmlns:a16="http://schemas.microsoft.com/office/drawing/2014/main" id="{5BBBA8C0-D25A-496A-9094-0FFDEDB26D9B}"/>
               </a:ext>
             </a:extLst>
           </p:cNvPr>
@@ -12549,7 +12468,7 @@
           <p:cNvPr id="13" name="">
             <a:extLst xmlns:a="http://schemas.openxmlformats.org/drawingml/2006/main">
               <a:ext uri="{FF2B5EF4-FFF2-40B4-BE49-F238E27FC236}">
-                <a16:creationId xmlns:a16="http://schemas.microsoft.com/office/drawing/2014/main" id="{094626A7-742A-4820-BC65-B8D74DFF5F0E}"/>
+                <a16:creationId xmlns:a16="http://schemas.microsoft.com/office/drawing/2014/main" id="{1022AAC1-067E-45C8-93A0-E14DB68D30A9}"/>
               </a:ext>
             </a:extLst>
           </p:cNvPr>
@@ -12705,7 +12624,7 @@
           <p:cNvPr id="14" name="">
             <a:extLst xmlns:a="http://schemas.openxmlformats.org/drawingml/2006/main">
               <a:ext uri="{FF2B5EF4-FFF2-40B4-BE49-F238E27FC236}">
-                <a16:creationId xmlns:a16="http://schemas.microsoft.com/office/drawing/2014/main" id="{878A327E-A8C1-482F-8BD2-2EBF7D213B5F}"/>
+                <a16:creationId xmlns:a16="http://schemas.microsoft.com/office/drawing/2014/main" id="{CAEDA6C6-ED48-453C-9EA6-9B40373C3DC0}"/>
               </a:ext>
             </a:extLst>
           </p:cNvPr>
@@ -12861,7 +12780,7 @@
           <p:cNvPr id="15" name="">
             <a:extLst xmlns:a="http://schemas.openxmlformats.org/drawingml/2006/main">
               <a:ext uri="{FF2B5EF4-FFF2-40B4-BE49-F238E27FC236}">
-                <a16:creationId xmlns:a16="http://schemas.microsoft.com/office/drawing/2014/main" id="{C167DC7E-9D29-44A1-A209-389E5AFF2891}"/>
+                <a16:creationId xmlns:a16="http://schemas.microsoft.com/office/drawing/2014/main" id="{2812CD8A-4276-4721-A18F-668A6F7BBEC2}"/>
               </a:ext>
             </a:extLst>
           </p:cNvPr>
@@ -13017,7 +12936,7 @@
           <p:cNvPr id="16" name="">
             <a:extLst xmlns:a="http://schemas.openxmlformats.org/drawingml/2006/main">
               <a:ext uri="{FF2B5EF4-FFF2-40B4-BE49-F238E27FC236}">
-                <a16:creationId xmlns:a16="http://schemas.microsoft.com/office/drawing/2014/main" id="{13CB37FA-A8DE-4A9A-9B28-1DC1E5FD4A44}"/>
+                <a16:creationId xmlns:a16="http://schemas.microsoft.com/office/drawing/2014/main" id="{4E78BAD0-BB7D-4F78-85F9-772E09362406}"/>
               </a:ext>
             </a:extLst>
           </p:cNvPr>
@@ -13173,7 +13092,7 @@
           <p:cNvPr id="17" name="">
             <a:extLst xmlns:a="http://schemas.openxmlformats.org/drawingml/2006/main">
               <a:ext uri="{FF2B5EF4-FFF2-40B4-BE49-F238E27FC236}">
-                <a16:creationId xmlns:a16="http://schemas.microsoft.com/office/drawing/2014/main" id="{601CCAA5-E279-4E26-BDD3-3AA3062A3F79}"/>
+                <a16:creationId xmlns:a16="http://schemas.microsoft.com/office/drawing/2014/main" id="{D153EA6E-336A-4352-8D0E-5E3C642C53C1}"/>
               </a:ext>
             </a:extLst>
           </p:cNvPr>
@@ -13329,7 +13248,7 @@
           <p:cNvPr id="18" name="">
             <a:extLst xmlns:a="http://schemas.openxmlformats.org/drawingml/2006/main">
               <a:ext uri="{FF2B5EF4-FFF2-40B4-BE49-F238E27FC236}">
-                <a16:creationId xmlns:a16="http://schemas.microsoft.com/office/drawing/2014/main" id="{311F1DB7-70F7-4E33-BC35-09DCFDFC440A}"/>
+                <a16:creationId xmlns:a16="http://schemas.microsoft.com/office/drawing/2014/main" id="{D62EAB96-7E53-49E9-8258-DF1F8399FFCE}"/>
               </a:ext>
             </a:extLst>
           </p:cNvPr>
@@ -13483,1463 +13402,7 @@
     </p:spTree>
     <p:extLst>
       <p:ext uri="{BB962C8B-B14F-4D97-AF65-F5344CB8AC3E}">
-        <p14:creationId xmlns:p14="http://schemas.microsoft.com/office/powerpoint/2010/main" val="193971811"/>
-      </p:ext>
-    </p:extLst>
-  </p:cSld>
-</p:sld>
-</file>
-
-<file path=ppt/slides/slide7.xml><?xml version="1.0" encoding="utf-8"?>
-<p:sld xmlns:p="http://schemas.openxmlformats.org/presentationml/2006/main">
-  <p:cSld>
-    <p:bg>
-      <p:bgPr>
-        <a:solidFill xmlns:a="http://schemas.openxmlformats.org/drawingml/2006/main">
-          <a:srgbClr val="F7F8FA"/>
-        </a:solidFill>
-      </p:bgPr>
-    </p:bg>
-    <p:spTree>
-      <p:nvGrpSpPr>
-        <p:cNvPr id="1" name=""/>
-        <p:cNvGrpSpPr/>
-        <p:nvPr/>
-      </p:nvGrpSpPr>
-      <p:grpSpPr>
-        <a:xfrm xmlns:a="http://schemas.openxmlformats.org/drawingml/2006/main"/>
-      </p:grpSpPr>
-      <p:sp>
-        <p:nvSpPr>
-          <p:cNvPr id="10" name="">
-            <a:extLst xmlns:a="http://schemas.openxmlformats.org/drawingml/2006/main">
-              <a:ext uri="{FF2B5EF4-FFF2-40B4-BE49-F238E27FC236}">
-                <a16:creationId xmlns:a16="http://schemas.microsoft.com/office/drawing/2014/main" id="{DDA1157C-6F57-47FB-A877-AF69998311D1}"/>
-              </a:ext>
-            </a:extLst>
-          </p:cNvPr>
-          <p:cNvSpPr>
-            <a:spLocks xmlns:a="http://schemas.openxmlformats.org/drawingml/2006/main" noGrp="1"/>
-          </p:cNvSpPr>
-          <p:nvPr/>
-        </p:nvSpPr>
-        <p:spPr>
-          <a:xfrm xmlns:a="http://schemas.openxmlformats.org/drawingml/2006/main">
-            <a:off x="609600" y="495300"/>
-            <a:ext cx="10953750" cy="952500"/>
-          </a:xfrm>
-          <a:prstGeom xmlns:a="http://schemas.openxmlformats.org/drawingml/2006/main" prst="rect">
-            <a:avLst/>
-          </a:prstGeom>
-          <a:noFill xmlns:a="http://schemas.openxmlformats.org/drawingml/2006/main"/>
-          <a:ln xmlns:a="http://schemas.openxmlformats.org/drawingml/2006/main" w="0">
-            <a:noFill/>
-          </a:ln>
-        </p:spPr>
-        <p:txBody>
-          <a:bodyPr xmlns:a="http://schemas.openxmlformats.org/drawingml/2006/main"/>
-          <a:lstStyle xmlns:a="http://schemas.openxmlformats.org/drawingml/2006/main">
-            <a:defPPr>
-              <a:defRPr sz="3300" b="1">
-                <a:solidFill>
-                  <a:srgbClr val="19232F"/>
-                </a:solidFill>
-                <a:latin typeface="Arial"/>
-                <a:ea typeface="Arial"/>
-                <a:cs typeface="Arial"/>
-              </a:defRPr>
-            </a:defPPr>
-            <a:lvl1pPr>
-              <a:defRPr sz="3300" b="1">
-                <a:solidFill>
-                  <a:srgbClr val="19232F"/>
-                </a:solidFill>
-                <a:latin typeface="Arial"/>
-                <a:ea typeface="Arial"/>
-                <a:cs typeface="Arial"/>
-              </a:defRPr>
-            </a:lvl1pPr>
-            <a:lvl2pPr>
-              <a:defRPr sz="3300" b="1">
-                <a:solidFill>
-                  <a:srgbClr val="19232F"/>
-                </a:solidFill>
-                <a:latin typeface="Arial"/>
-                <a:ea typeface="Arial"/>
-                <a:cs typeface="Arial"/>
-              </a:defRPr>
-            </a:lvl2pPr>
-            <a:lvl3pPr>
-              <a:defRPr sz="3300" b="1">
-                <a:solidFill>
-                  <a:srgbClr val="19232F"/>
-                </a:solidFill>
-                <a:latin typeface="Arial"/>
-                <a:ea typeface="Arial"/>
-                <a:cs typeface="Arial"/>
-              </a:defRPr>
-            </a:lvl3pPr>
-            <a:lvl4pPr>
-              <a:defRPr sz="3300" b="1">
-                <a:solidFill>
-                  <a:srgbClr val="19232F"/>
-                </a:solidFill>
-                <a:latin typeface="Arial"/>
-                <a:ea typeface="Arial"/>
-                <a:cs typeface="Arial"/>
-              </a:defRPr>
-            </a:lvl4pPr>
-            <a:lvl5pPr>
-              <a:defRPr sz="3300" b="1">
-                <a:solidFill>
-                  <a:srgbClr val="19232F"/>
-                </a:solidFill>
-                <a:latin typeface="Arial"/>
-                <a:ea typeface="Arial"/>
-                <a:cs typeface="Arial"/>
-              </a:defRPr>
-            </a:lvl5pPr>
-            <a:lvl6pPr>
-              <a:defRPr sz="3300" b="1">
-                <a:solidFill>
-                  <a:srgbClr val="19232F"/>
-                </a:solidFill>
-                <a:latin typeface="Arial"/>
-                <a:ea typeface="Arial"/>
-                <a:cs typeface="Arial"/>
-              </a:defRPr>
-            </a:lvl6pPr>
-            <a:lvl7pPr>
-              <a:defRPr sz="3300" b="1">
-                <a:solidFill>
-                  <a:srgbClr val="19232F"/>
-                </a:solidFill>
-                <a:latin typeface="Arial"/>
-                <a:ea typeface="Arial"/>
-                <a:cs typeface="Arial"/>
-              </a:defRPr>
-            </a:lvl7pPr>
-            <a:lvl8pPr>
-              <a:defRPr sz="3300" b="1">
-                <a:solidFill>
-                  <a:srgbClr val="19232F"/>
-                </a:solidFill>
-                <a:latin typeface="Arial"/>
-                <a:ea typeface="Arial"/>
-                <a:cs typeface="Arial"/>
-              </a:defRPr>
-            </a:lvl8pPr>
-            <a:lvl9pPr>
-              <a:defRPr sz="3300" b="1">
-                <a:solidFill>
-                  <a:srgbClr val="19232F"/>
-                </a:solidFill>
-                <a:latin typeface="Arial"/>
-                <a:ea typeface="Arial"/>
-                <a:cs typeface="Arial"/>
-              </a:defRPr>
-            </a:lvl9pPr>
-          </a:lstStyle>
-          <a:p xmlns:a="http://schemas.openxmlformats.org/drawingml/2006/main">
-            <a:pPr>
-              <a:defRPr sz="3300" b="1">
-                <a:solidFill>
-                  <a:srgbClr val="19232F"/>
-                </a:solidFill>
-                <a:latin typeface="Arial"/>
-                <a:ea typeface="Arial"/>
-                <a:cs typeface="Arial"/>
-              </a:defRPr>
-            </a:pPr>
-            <a:r>
-              <a:rPr sz="3300" b="1">
-                <a:solidFill>
-                  <a:srgbClr val="19232F"/>
-                </a:solidFill>
-                <a:latin typeface="Arial"/>
-                <a:ea typeface="Arial"/>
-                <a:cs typeface="Arial"/>
-              </a:rPr>
-              <a:t>Demo trực tiếp và bước tiếp theo</a:t>
-            </a:r>
-          </a:p>
-        </p:txBody>
-      </p:sp>
-      <p:sp>
-        <p:nvSpPr>
-          <p:cNvPr id="2" name="">
-            <a:extLst xmlns:a="http://schemas.openxmlformats.org/drawingml/2006/main">
-              <a:ext uri="{FF2B5EF4-FFF2-40B4-BE49-F238E27FC236}">
-                <a16:creationId xmlns:a16="http://schemas.microsoft.com/office/drawing/2014/main" id="{1D1825D8-3110-4CAF-AB02-B397ABDF1298}"/>
-              </a:ext>
-            </a:extLst>
-          </p:cNvPr>
-          <p:cNvSpPr>
-            <a:spLocks xmlns:a="http://schemas.openxmlformats.org/drawingml/2006/main" noGrp="1"/>
-          </p:cNvSpPr>
-          <p:nvPr/>
-        </p:nvSpPr>
-        <p:spPr>
-          <a:xfrm xmlns:a="http://schemas.openxmlformats.org/drawingml/2006/main">
-            <a:off x="609600" y="1485900"/>
-            <a:ext cx="10953750" cy="714375"/>
-          </a:xfrm>
-          <a:prstGeom xmlns:a="http://schemas.openxmlformats.org/drawingml/2006/main" prst="rect">
-            <a:avLst/>
-          </a:prstGeom>
-          <a:noFill xmlns:a="http://schemas.openxmlformats.org/drawingml/2006/main"/>
-          <a:ln xmlns:a="http://schemas.openxmlformats.org/drawingml/2006/main" w="0">
-            <a:noFill/>
-          </a:ln>
-        </p:spPr>
-        <p:txBody>
-          <a:bodyPr xmlns:a="http://schemas.openxmlformats.org/drawingml/2006/main"/>
-          <a:lstStyle xmlns:a="http://schemas.openxmlformats.org/drawingml/2006/main">
-            <a:defPPr>
-              <a:defRPr sz="1875" b="0">
-                <a:solidFill>
-                  <a:srgbClr val="596675"/>
-                </a:solidFill>
-                <a:latin typeface="Arial"/>
-                <a:ea typeface="Arial"/>
-                <a:cs typeface="Arial"/>
-              </a:defRPr>
-            </a:defPPr>
-            <a:lvl1pPr>
-              <a:defRPr sz="1875" b="0">
-                <a:solidFill>
-                  <a:srgbClr val="596675"/>
-                </a:solidFill>
-                <a:latin typeface="Arial"/>
-                <a:ea typeface="Arial"/>
-                <a:cs typeface="Arial"/>
-              </a:defRPr>
-            </a:lvl1pPr>
-            <a:lvl2pPr>
-              <a:defRPr sz="1875" b="0">
-                <a:solidFill>
-                  <a:srgbClr val="596675"/>
-                </a:solidFill>
-                <a:latin typeface="Arial"/>
-                <a:ea typeface="Arial"/>
-                <a:cs typeface="Arial"/>
-              </a:defRPr>
-            </a:lvl2pPr>
-            <a:lvl3pPr>
-              <a:defRPr sz="1875" b="0">
-                <a:solidFill>
-                  <a:srgbClr val="596675"/>
-                </a:solidFill>
-                <a:latin typeface="Arial"/>
-                <a:ea typeface="Arial"/>
-                <a:cs typeface="Arial"/>
-              </a:defRPr>
-            </a:lvl3pPr>
-            <a:lvl4pPr>
-              <a:defRPr sz="1875" b="0">
-                <a:solidFill>
-                  <a:srgbClr val="596675"/>
-                </a:solidFill>
-                <a:latin typeface="Arial"/>
-                <a:ea typeface="Arial"/>
-                <a:cs typeface="Arial"/>
-              </a:defRPr>
-            </a:lvl4pPr>
-            <a:lvl5pPr>
-              <a:defRPr sz="1875" b="0">
-                <a:solidFill>
-                  <a:srgbClr val="596675"/>
-                </a:solidFill>
-                <a:latin typeface="Arial"/>
-                <a:ea typeface="Arial"/>
-                <a:cs typeface="Arial"/>
-              </a:defRPr>
-            </a:lvl5pPr>
-            <a:lvl6pPr>
-              <a:defRPr sz="1875" b="0">
-                <a:solidFill>
-                  <a:srgbClr val="596675"/>
-                </a:solidFill>
-                <a:latin typeface="Arial"/>
-                <a:ea typeface="Arial"/>
-                <a:cs typeface="Arial"/>
-              </a:defRPr>
-            </a:lvl6pPr>
-            <a:lvl7pPr>
-              <a:defRPr sz="1875" b="0">
-                <a:solidFill>
-                  <a:srgbClr val="596675"/>
-                </a:solidFill>
-                <a:latin typeface="Arial"/>
-                <a:ea typeface="Arial"/>
-                <a:cs typeface="Arial"/>
-              </a:defRPr>
-            </a:lvl7pPr>
-            <a:lvl8pPr>
-              <a:defRPr sz="1875" b="0">
-                <a:solidFill>
-                  <a:srgbClr val="596675"/>
-                </a:solidFill>
-                <a:latin typeface="Arial"/>
-                <a:ea typeface="Arial"/>
-                <a:cs typeface="Arial"/>
-              </a:defRPr>
-            </a:lvl8pPr>
-            <a:lvl9pPr>
-              <a:defRPr sz="1875" b="0">
-                <a:solidFill>
-                  <a:srgbClr val="596675"/>
-                </a:solidFill>
-                <a:latin typeface="Arial"/>
-                <a:ea typeface="Arial"/>
-                <a:cs typeface="Arial"/>
-              </a:defRPr>
-            </a:lvl9pPr>
-          </a:lstStyle>
-          <a:p xmlns:a="http://schemas.openxmlformats.org/drawingml/2006/main">
-            <a:pPr>
-              <a:defRPr sz="1875" b="0">
-                <a:solidFill>
-                  <a:srgbClr val="596675"/>
-                </a:solidFill>
-                <a:latin typeface="Arial"/>
-                <a:ea typeface="Arial"/>
-                <a:cs typeface="Arial"/>
-              </a:defRPr>
-            </a:pPr>
-            <a:r>
-              <a:rPr sz="1875" b="0">
-                <a:solidFill>
-                  <a:srgbClr val="596675"/>
-                </a:solidFill>
-                <a:latin typeface="Arial"/>
-                <a:ea typeface="Arial"/>
-                <a:cs typeface="Arial"/>
-              </a:rPr>
-              <a:t>MVP công khai, kết quả có log và giới hạn rõ ràng</a:t>
-            </a:r>
-          </a:p>
-        </p:txBody>
-      </p:sp>
-      <p:sp>
-        <p:nvSpPr>
-          <p:cNvPr id="3" name="">
-            <a:extLst xmlns:a="http://schemas.openxmlformats.org/drawingml/2006/main">
-              <a:ext uri="{FF2B5EF4-FFF2-40B4-BE49-F238E27FC236}">
-                <a16:creationId xmlns:a16="http://schemas.microsoft.com/office/drawing/2014/main" id="{E57D5EBD-B149-4DDC-B943-C12223F827F3}"/>
-              </a:ext>
-            </a:extLst>
-          </p:cNvPr>
-          <p:cNvSpPr>
-            <a:spLocks xmlns:a="http://schemas.openxmlformats.org/drawingml/2006/main" noGrp="1"/>
-          </p:cNvSpPr>
-          <p:nvPr/>
-        </p:nvSpPr>
-        <p:spPr>
-          <a:xfrm xmlns:a="http://schemas.openxmlformats.org/drawingml/2006/main">
-            <a:off x="609600" y="6429375"/>
-            <a:ext cx="10001250" cy="228600"/>
-          </a:xfrm>
-          <a:prstGeom xmlns:a="http://schemas.openxmlformats.org/drawingml/2006/main" prst="rect">
-            <a:avLst/>
-          </a:prstGeom>
-          <a:noFill xmlns:a="http://schemas.openxmlformats.org/drawingml/2006/main"/>
-          <a:ln xmlns:a="http://schemas.openxmlformats.org/drawingml/2006/main" w="0">
-            <a:noFill/>
-          </a:ln>
-        </p:spPr>
-        <p:txBody>
-          <a:bodyPr xmlns:a="http://schemas.openxmlformats.org/drawingml/2006/main"/>
-          <a:lstStyle xmlns:a="http://schemas.openxmlformats.org/drawingml/2006/main">
-            <a:defPPr>
-              <a:defRPr sz="1200" b="0">
-                <a:solidFill>
-                  <a:srgbClr val="596675"/>
-                </a:solidFill>
-                <a:latin typeface="Arial"/>
-                <a:ea typeface="Arial"/>
-                <a:cs typeface="Arial"/>
-              </a:defRPr>
-            </a:defPPr>
-            <a:lvl1pPr>
-              <a:defRPr sz="1200" b="0">
-                <a:solidFill>
-                  <a:srgbClr val="596675"/>
-                </a:solidFill>
-                <a:latin typeface="Arial"/>
-                <a:ea typeface="Arial"/>
-                <a:cs typeface="Arial"/>
-              </a:defRPr>
-            </a:lvl1pPr>
-            <a:lvl2pPr>
-              <a:defRPr sz="1200" b="0">
-                <a:solidFill>
-                  <a:srgbClr val="596675"/>
-                </a:solidFill>
-                <a:latin typeface="Arial"/>
-                <a:ea typeface="Arial"/>
-                <a:cs typeface="Arial"/>
-              </a:defRPr>
-            </a:lvl2pPr>
-            <a:lvl3pPr>
-              <a:defRPr sz="1200" b="0">
-                <a:solidFill>
-                  <a:srgbClr val="596675"/>
-                </a:solidFill>
-                <a:latin typeface="Arial"/>
-                <a:ea typeface="Arial"/>
-                <a:cs typeface="Arial"/>
-              </a:defRPr>
-            </a:lvl3pPr>
-            <a:lvl4pPr>
-              <a:defRPr sz="1200" b="0">
-                <a:solidFill>
-                  <a:srgbClr val="596675"/>
-                </a:solidFill>
-                <a:latin typeface="Arial"/>
-                <a:ea typeface="Arial"/>
-                <a:cs typeface="Arial"/>
-              </a:defRPr>
-            </a:lvl4pPr>
-            <a:lvl5pPr>
-              <a:defRPr sz="1200" b="0">
-                <a:solidFill>
-                  <a:srgbClr val="596675"/>
-                </a:solidFill>
-                <a:latin typeface="Arial"/>
-                <a:ea typeface="Arial"/>
-                <a:cs typeface="Arial"/>
-              </a:defRPr>
-            </a:lvl5pPr>
-            <a:lvl6pPr>
-              <a:defRPr sz="1200" b="0">
-                <a:solidFill>
-                  <a:srgbClr val="596675"/>
-                </a:solidFill>
-                <a:latin typeface="Arial"/>
-                <a:ea typeface="Arial"/>
-                <a:cs typeface="Arial"/>
-              </a:defRPr>
-            </a:lvl6pPr>
-            <a:lvl7pPr>
-              <a:defRPr sz="1200" b="0">
-                <a:solidFill>
-                  <a:srgbClr val="596675"/>
-                </a:solidFill>
-                <a:latin typeface="Arial"/>
-                <a:ea typeface="Arial"/>
-                <a:cs typeface="Arial"/>
-              </a:defRPr>
-            </a:lvl7pPr>
-            <a:lvl8pPr>
-              <a:defRPr sz="1200" b="0">
-                <a:solidFill>
-                  <a:srgbClr val="596675"/>
-                </a:solidFill>
-                <a:latin typeface="Arial"/>
-                <a:ea typeface="Arial"/>
-                <a:cs typeface="Arial"/>
-              </a:defRPr>
-            </a:lvl8pPr>
-            <a:lvl9pPr>
-              <a:defRPr sz="1200" b="0">
-                <a:solidFill>
-                  <a:srgbClr val="596675"/>
-                </a:solidFill>
-                <a:latin typeface="Arial"/>
-                <a:ea typeface="Arial"/>
-                <a:cs typeface="Arial"/>
-              </a:defRPr>
-            </a:lvl9pPr>
-          </a:lstStyle>
-          <a:p xmlns:a="http://schemas.openxmlformats.org/drawingml/2006/main">
-            <a:pPr>
-              <a:defRPr sz="1200" b="0">
-                <a:solidFill>
-                  <a:srgbClr val="596675"/>
-                </a:solidFill>
-                <a:latin typeface="Arial"/>
-                <a:ea typeface="Arial"/>
-                <a:cs typeface="Arial"/>
-              </a:defRPr>
-            </a:pPr>
-            <a:r>
-              <a:rPr sz="1200" b="0">
-                <a:solidFill>
-                  <a:srgbClr val="596675"/>
-                </a:solidFill>
-                <a:latin typeface="Arial"/>
-                <a:ea typeface="Arial"/>
-                <a:cs typeface="Arial"/>
-              </a:rPr>
-              <a:t>M38 Prelabel Studio   /   Sakana   /   Demo Day 2026</a:t>
-            </a:r>
-          </a:p>
-        </p:txBody>
-      </p:sp>
-      <p:sp>
-        <p:nvSpPr>
-          <p:cNvPr id="4" name="">
-            <a:extLst xmlns:a="http://schemas.openxmlformats.org/drawingml/2006/main">
-              <a:ext uri="{FF2B5EF4-FFF2-40B4-BE49-F238E27FC236}">
-                <a16:creationId xmlns:a16="http://schemas.microsoft.com/office/drawing/2014/main" id="{63052838-6754-4B23-A881-D6FEC3166E79}"/>
-              </a:ext>
-            </a:extLst>
-          </p:cNvPr>
-          <p:cNvSpPr>
-            <a:spLocks xmlns:a="http://schemas.openxmlformats.org/drawingml/2006/main" noGrp="1"/>
-          </p:cNvSpPr>
-          <p:nvPr/>
-        </p:nvSpPr>
-        <p:spPr>
-          <a:xfrm xmlns:a="http://schemas.openxmlformats.org/drawingml/2006/main">
-            <a:off x="11144250" y="6429375"/>
-            <a:ext cx="476250" cy="228600"/>
-          </a:xfrm>
-          <a:prstGeom xmlns:a="http://schemas.openxmlformats.org/drawingml/2006/main" prst="rect">
-            <a:avLst/>
-          </a:prstGeom>
-          <a:noFill xmlns:a="http://schemas.openxmlformats.org/drawingml/2006/main"/>
-          <a:ln xmlns:a="http://schemas.openxmlformats.org/drawingml/2006/main" w="0">
-            <a:noFill/>
-          </a:ln>
-        </p:spPr>
-        <p:txBody>
-          <a:bodyPr xmlns:a="http://schemas.openxmlformats.org/drawingml/2006/main"/>
-          <a:lstStyle xmlns:a="http://schemas.openxmlformats.org/drawingml/2006/main">
-            <a:defPPr>
-              <a:defRPr sz="1200" b="0">
-                <a:solidFill>
-                  <a:srgbClr val="596675"/>
-                </a:solidFill>
-                <a:latin typeface="Arial"/>
-                <a:ea typeface="Arial"/>
-                <a:cs typeface="Arial"/>
-              </a:defRPr>
-            </a:defPPr>
-            <a:lvl1pPr>
-              <a:defRPr sz="1200" b="0">
-                <a:solidFill>
-                  <a:srgbClr val="596675"/>
-                </a:solidFill>
-                <a:latin typeface="Arial"/>
-                <a:ea typeface="Arial"/>
-                <a:cs typeface="Arial"/>
-              </a:defRPr>
-            </a:lvl1pPr>
-            <a:lvl2pPr>
-              <a:defRPr sz="1200" b="0">
-                <a:solidFill>
-                  <a:srgbClr val="596675"/>
-                </a:solidFill>
-                <a:latin typeface="Arial"/>
-                <a:ea typeface="Arial"/>
-                <a:cs typeface="Arial"/>
-              </a:defRPr>
-            </a:lvl2pPr>
-            <a:lvl3pPr>
-              <a:defRPr sz="1200" b="0">
-                <a:solidFill>
-                  <a:srgbClr val="596675"/>
-                </a:solidFill>
-                <a:latin typeface="Arial"/>
-                <a:ea typeface="Arial"/>
-                <a:cs typeface="Arial"/>
-              </a:defRPr>
-            </a:lvl3pPr>
-            <a:lvl4pPr>
-              <a:defRPr sz="1200" b="0">
-                <a:solidFill>
-                  <a:srgbClr val="596675"/>
-                </a:solidFill>
-                <a:latin typeface="Arial"/>
-                <a:ea typeface="Arial"/>
-                <a:cs typeface="Arial"/>
-              </a:defRPr>
-            </a:lvl4pPr>
-            <a:lvl5pPr>
-              <a:defRPr sz="1200" b="0">
-                <a:solidFill>
-                  <a:srgbClr val="596675"/>
-                </a:solidFill>
-                <a:latin typeface="Arial"/>
-                <a:ea typeface="Arial"/>
-                <a:cs typeface="Arial"/>
-              </a:defRPr>
-            </a:lvl5pPr>
-            <a:lvl6pPr>
-              <a:defRPr sz="1200" b="0">
-                <a:solidFill>
-                  <a:srgbClr val="596675"/>
-                </a:solidFill>
-                <a:latin typeface="Arial"/>
-                <a:ea typeface="Arial"/>
-                <a:cs typeface="Arial"/>
-              </a:defRPr>
-            </a:lvl6pPr>
-            <a:lvl7pPr>
-              <a:defRPr sz="1200" b="0">
-                <a:solidFill>
-                  <a:srgbClr val="596675"/>
-                </a:solidFill>
-                <a:latin typeface="Arial"/>
-                <a:ea typeface="Arial"/>
-                <a:cs typeface="Arial"/>
-              </a:defRPr>
-            </a:lvl7pPr>
-            <a:lvl8pPr>
-              <a:defRPr sz="1200" b="0">
-                <a:solidFill>
-                  <a:srgbClr val="596675"/>
-                </a:solidFill>
-                <a:latin typeface="Arial"/>
-                <a:ea typeface="Arial"/>
-                <a:cs typeface="Arial"/>
-              </a:defRPr>
-            </a:lvl8pPr>
-            <a:lvl9pPr>
-              <a:defRPr sz="1200" b="0">
-                <a:solidFill>
-                  <a:srgbClr val="596675"/>
-                </a:solidFill>
-                <a:latin typeface="Arial"/>
-                <a:ea typeface="Arial"/>
-                <a:cs typeface="Arial"/>
-              </a:defRPr>
-            </a:lvl9pPr>
-          </a:lstStyle>
-          <a:p xmlns:a="http://schemas.openxmlformats.org/drawingml/2006/main">
-            <a:pPr>
-              <a:defRPr sz="1200" b="0">
-                <a:solidFill>
-                  <a:srgbClr val="596675"/>
-                </a:solidFill>
-                <a:latin typeface="Arial"/>
-                <a:ea typeface="Arial"/>
-                <a:cs typeface="Arial"/>
-              </a:defRPr>
-            </a:pPr>
-            <a:r>
-              <a:rPr sz="1200" b="0">
-                <a:solidFill>
-                  <a:srgbClr val="596675"/>
-                </a:solidFill>
-                <a:latin typeface="Arial"/>
-                <a:ea typeface="Arial"/>
-                <a:cs typeface="Arial"/>
-              </a:rPr>
-              <a:t>07</a:t>
-            </a:r>
-          </a:p>
-        </p:txBody>
-      </p:sp>
-      <p:sp>
-        <p:nvSpPr>
-          <p:cNvPr id="5" name="">
-            <a:extLst xmlns:a="http://schemas.openxmlformats.org/drawingml/2006/main">
-              <a:ext uri="{FF2B5EF4-FFF2-40B4-BE49-F238E27FC236}">
-                <a16:creationId xmlns:a16="http://schemas.microsoft.com/office/drawing/2014/main" id="{94F901A0-FBDE-4C91-BBBE-A5BF85ADE529}"/>
-              </a:ext>
-            </a:extLst>
-          </p:cNvPr>
-          <p:cNvSpPr>
-            <a:spLocks xmlns:a="http://schemas.openxmlformats.org/drawingml/2006/main" noGrp="1"/>
-          </p:cNvSpPr>
-          <p:nvPr/>
-        </p:nvSpPr>
-        <p:spPr>
-          <a:xfrm xmlns:a="http://schemas.openxmlformats.org/drawingml/2006/main">
-            <a:off x="609600" y="2571750"/>
-            <a:ext cx="10477500" cy="476250"/>
-          </a:xfrm>
-          <a:prstGeom xmlns:a="http://schemas.openxmlformats.org/drawingml/2006/main" prst="rect">
-            <a:avLst/>
-          </a:prstGeom>
-          <a:noFill xmlns:a="http://schemas.openxmlformats.org/drawingml/2006/main"/>
-          <a:ln xmlns:a="http://schemas.openxmlformats.org/drawingml/2006/main" w="0">
-            <a:noFill/>
-          </a:ln>
-        </p:spPr>
-        <p:txBody>
-          <a:bodyPr xmlns:a="http://schemas.openxmlformats.org/drawingml/2006/main"/>
-          <a:lstStyle xmlns:a="http://schemas.openxmlformats.org/drawingml/2006/main">
-            <a:defPPr>
-              <a:defRPr sz="2400" b="1">
-                <a:solidFill>
-                  <a:srgbClr val="B74219"/>
-                </a:solidFill>
-                <a:latin typeface="Arial"/>
-                <a:ea typeface="Arial"/>
-                <a:cs typeface="Arial"/>
-              </a:defRPr>
-            </a:defPPr>
-            <a:lvl1pPr>
-              <a:defRPr sz="2400" b="1">
-                <a:solidFill>
-                  <a:srgbClr val="B74219"/>
-                </a:solidFill>
-                <a:latin typeface="Arial"/>
-                <a:ea typeface="Arial"/>
-                <a:cs typeface="Arial"/>
-              </a:defRPr>
-            </a:lvl1pPr>
-            <a:lvl2pPr>
-              <a:defRPr sz="2400" b="1">
-                <a:solidFill>
-                  <a:srgbClr val="B74219"/>
-                </a:solidFill>
-                <a:latin typeface="Arial"/>
-                <a:ea typeface="Arial"/>
-                <a:cs typeface="Arial"/>
-              </a:defRPr>
-            </a:lvl2pPr>
-            <a:lvl3pPr>
-              <a:defRPr sz="2400" b="1">
-                <a:solidFill>
-                  <a:srgbClr val="B74219"/>
-                </a:solidFill>
-                <a:latin typeface="Arial"/>
-                <a:ea typeface="Arial"/>
-                <a:cs typeface="Arial"/>
-              </a:defRPr>
-            </a:lvl3pPr>
-            <a:lvl4pPr>
-              <a:defRPr sz="2400" b="1">
-                <a:solidFill>
-                  <a:srgbClr val="B74219"/>
-                </a:solidFill>
-                <a:latin typeface="Arial"/>
-                <a:ea typeface="Arial"/>
-                <a:cs typeface="Arial"/>
-              </a:defRPr>
-            </a:lvl4pPr>
-            <a:lvl5pPr>
-              <a:defRPr sz="2400" b="1">
-                <a:solidFill>
-                  <a:srgbClr val="B74219"/>
-                </a:solidFill>
-                <a:latin typeface="Arial"/>
-                <a:ea typeface="Arial"/>
-                <a:cs typeface="Arial"/>
-              </a:defRPr>
-            </a:lvl5pPr>
-            <a:lvl6pPr>
-              <a:defRPr sz="2400" b="1">
-                <a:solidFill>
-                  <a:srgbClr val="B74219"/>
-                </a:solidFill>
-                <a:latin typeface="Arial"/>
-                <a:ea typeface="Arial"/>
-                <a:cs typeface="Arial"/>
-              </a:defRPr>
-            </a:lvl6pPr>
-            <a:lvl7pPr>
-              <a:defRPr sz="2400" b="1">
-                <a:solidFill>
-                  <a:srgbClr val="B74219"/>
-                </a:solidFill>
-                <a:latin typeface="Arial"/>
-                <a:ea typeface="Arial"/>
-                <a:cs typeface="Arial"/>
-              </a:defRPr>
-            </a:lvl7pPr>
-            <a:lvl8pPr>
-              <a:defRPr sz="2400" b="1">
-                <a:solidFill>
-                  <a:srgbClr val="B74219"/>
-                </a:solidFill>
-                <a:latin typeface="Arial"/>
-                <a:ea typeface="Arial"/>
-                <a:cs typeface="Arial"/>
-              </a:defRPr>
-            </a:lvl8pPr>
-            <a:lvl9pPr>
-              <a:defRPr sz="2400" b="1">
-                <a:solidFill>
-                  <a:srgbClr val="B74219"/>
-                </a:solidFill>
-                <a:latin typeface="Arial"/>
-                <a:ea typeface="Arial"/>
-                <a:cs typeface="Arial"/>
-              </a:defRPr>
-            </a:lvl9pPr>
-          </a:lstStyle>
-          <a:p xmlns:a="http://schemas.openxmlformats.org/drawingml/2006/main">
-            <a:pPr>
-              <a:defRPr sz="2400" b="1">
-                <a:solidFill>
-                  <a:srgbClr val="B74219"/>
-                </a:solidFill>
-                <a:latin typeface="Arial"/>
-                <a:ea typeface="Arial"/>
-                <a:cs typeface="Arial"/>
-              </a:defRPr>
-            </a:pPr>
-            <a:r>
-              <a:rPr sz="2400" b="1">
-                <a:solidFill>
-                  <a:srgbClr val="B74219"/>
-                </a:solidFill>
-                <a:latin typeface="Arial"/>
-                <a:ea typeface="Arial"/>
-                <a:cs typeface="Arial"/>
-              </a:rPr>
-              <a:t>Thử sản phẩm</a:t>
-            </a:r>
-          </a:p>
-        </p:txBody>
-      </p:sp>
-      <p:sp>
-        <p:nvSpPr>
-          <p:cNvPr id="6" name="">
-            <a:extLst xmlns:a="http://schemas.openxmlformats.org/drawingml/2006/main">
-              <a:ext uri="{FF2B5EF4-FFF2-40B4-BE49-F238E27FC236}">
-                <a16:creationId xmlns:a16="http://schemas.microsoft.com/office/drawing/2014/main" id="{2807E9AA-15F9-4B44-B25F-2C66948A01D1}"/>
-              </a:ext>
-            </a:extLst>
-          </p:cNvPr>
-          <p:cNvSpPr>
-            <a:spLocks xmlns:a="http://schemas.openxmlformats.org/drawingml/2006/main" noGrp="1"/>
-          </p:cNvSpPr>
-          <p:nvPr/>
-        </p:nvSpPr>
-        <p:spPr>
-          <a:xfrm xmlns:a="http://schemas.openxmlformats.org/drawingml/2006/main">
-            <a:off x="609600" y="3190875"/>
-            <a:ext cx="10953750" cy="523875"/>
-          </a:xfrm>
-          <a:prstGeom xmlns:a="http://schemas.openxmlformats.org/drawingml/2006/main" prst="rect">
-            <a:avLst/>
-          </a:prstGeom>
-          <a:noFill xmlns:a="http://schemas.openxmlformats.org/drawingml/2006/main"/>
-          <a:ln xmlns:a="http://schemas.openxmlformats.org/drawingml/2006/main" w="0">
-            <a:noFill/>
-          </a:ln>
-        </p:spPr>
-        <p:txBody>
-          <a:bodyPr xmlns:a="http://schemas.openxmlformats.org/drawingml/2006/main"/>
-          <a:lstStyle xmlns:a="http://schemas.openxmlformats.org/drawingml/2006/main">
-            <a:defPPr>
-              <a:defRPr sz="2400" b="0">
-                <a:solidFill>
-                  <a:srgbClr val="19232F"/>
-                </a:solidFill>
-                <a:latin typeface="Arial"/>
-                <a:ea typeface="Arial"/>
-                <a:cs typeface="Arial"/>
-              </a:defRPr>
-            </a:defPPr>
-            <a:lvl1pPr>
-              <a:defRPr sz="2400" b="0">
-                <a:solidFill>
-                  <a:srgbClr val="19232F"/>
-                </a:solidFill>
-                <a:latin typeface="Arial"/>
-                <a:ea typeface="Arial"/>
-                <a:cs typeface="Arial"/>
-              </a:defRPr>
-            </a:lvl1pPr>
-            <a:lvl2pPr>
-              <a:defRPr sz="2400" b="0">
-                <a:solidFill>
-                  <a:srgbClr val="19232F"/>
-                </a:solidFill>
-                <a:latin typeface="Arial"/>
-                <a:ea typeface="Arial"/>
-                <a:cs typeface="Arial"/>
-              </a:defRPr>
-            </a:lvl2pPr>
-            <a:lvl3pPr>
-              <a:defRPr sz="2400" b="0">
-                <a:solidFill>
-                  <a:srgbClr val="19232F"/>
-                </a:solidFill>
-                <a:latin typeface="Arial"/>
-                <a:ea typeface="Arial"/>
-                <a:cs typeface="Arial"/>
-              </a:defRPr>
-            </a:lvl3pPr>
-            <a:lvl4pPr>
-              <a:defRPr sz="2400" b="0">
-                <a:solidFill>
-                  <a:srgbClr val="19232F"/>
-                </a:solidFill>
-                <a:latin typeface="Arial"/>
-                <a:ea typeface="Arial"/>
-                <a:cs typeface="Arial"/>
-              </a:defRPr>
-            </a:lvl4pPr>
-            <a:lvl5pPr>
-              <a:defRPr sz="2400" b="0">
-                <a:solidFill>
-                  <a:srgbClr val="19232F"/>
-                </a:solidFill>
-                <a:latin typeface="Arial"/>
-                <a:ea typeface="Arial"/>
-                <a:cs typeface="Arial"/>
-              </a:defRPr>
-            </a:lvl5pPr>
-            <a:lvl6pPr>
-              <a:defRPr sz="2400" b="0">
-                <a:solidFill>
-                  <a:srgbClr val="19232F"/>
-                </a:solidFill>
-                <a:latin typeface="Arial"/>
-                <a:ea typeface="Arial"/>
-                <a:cs typeface="Arial"/>
-              </a:defRPr>
-            </a:lvl6pPr>
-            <a:lvl7pPr>
-              <a:defRPr sz="2400" b="0">
-                <a:solidFill>
-                  <a:srgbClr val="19232F"/>
-                </a:solidFill>
-                <a:latin typeface="Arial"/>
-                <a:ea typeface="Arial"/>
-                <a:cs typeface="Arial"/>
-              </a:defRPr>
-            </a:lvl7pPr>
-            <a:lvl8pPr>
-              <a:defRPr sz="2400" b="0">
-                <a:solidFill>
-                  <a:srgbClr val="19232F"/>
-                </a:solidFill>
-                <a:latin typeface="Arial"/>
-                <a:ea typeface="Arial"/>
-                <a:cs typeface="Arial"/>
-              </a:defRPr>
-            </a:lvl8pPr>
-            <a:lvl9pPr>
-              <a:defRPr sz="2400" b="0">
-                <a:solidFill>
-                  <a:srgbClr val="19232F"/>
-                </a:solidFill>
-                <a:latin typeface="Arial"/>
-                <a:ea typeface="Arial"/>
-                <a:cs typeface="Arial"/>
-              </a:defRPr>
-            </a:lvl9pPr>
-          </a:lstStyle>
-          <a:p xmlns:a="http://schemas.openxmlformats.org/drawingml/2006/main">
-            <a:pPr>
-              <a:defRPr sz="2400" b="0">
-                <a:solidFill>
-                  <a:srgbClr val="19232F"/>
-                </a:solidFill>
-                <a:latin typeface="Arial"/>
-                <a:ea typeface="Arial"/>
-                <a:cs typeface="Arial"/>
-              </a:defRPr>
-            </a:pPr>
-            <a:r>
-              <a:rPr sz="2400" b="0">
-                <a:solidFill>
-                  <a:srgbClr val="19232F"/>
-                </a:solidFill>
-                <a:latin typeface="Arial"/>
-                <a:ea typeface="Arial"/>
-                <a:cs typeface="Arial"/>
-              </a:rPr>
-              <a:t>manhld424.github.io/M38-Edge-PreLabeling/</a:t>
-            </a:r>
-          </a:p>
-        </p:txBody>
-      </p:sp>
-      <p:sp>
-        <p:nvSpPr>
-          <p:cNvPr id="7" name="">
-            <a:extLst xmlns:a="http://schemas.openxmlformats.org/drawingml/2006/main">
-              <a:ext uri="{FF2B5EF4-FFF2-40B4-BE49-F238E27FC236}">
-                <a16:creationId xmlns:a16="http://schemas.microsoft.com/office/drawing/2014/main" id="{C5A82A50-E928-4B08-BBDA-65FB56409013}"/>
-              </a:ext>
-            </a:extLst>
-          </p:cNvPr>
-          <p:cNvSpPr>
-            <a:spLocks xmlns:a="http://schemas.openxmlformats.org/drawingml/2006/main" noGrp="1"/>
-          </p:cNvSpPr>
-          <p:nvPr/>
-        </p:nvSpPr>
-        <p:spPr>
-          <a:xfrm xmlns:a="http://schemas.openxmlformats.org/drawingml/2006/main">
-            <a:off x="609600" y="4048125"/>
-            <a:ext cx="10477500" cy="476250"/>
-          </a:xfrm>
-          <a:prstGeom xmlns:a="http://schemas.openxmlformats.org/drawingml/2006/main" prst="rect">
-            <a:avLst/>
-          </a:prstGeom>
-          <a:noFill xmlns:a="http://schemas.openxmlformats.org/drawingml/2006/main"/>
-          <a:ln xmlns:a="http://schemas.openxmlformats.org/drawingml/2006/main" w="0">
-            <a:noFill/>
-          </a:ln>
-        </p:spPr>
-        <p:txBody>
-          <a:bodyPr xmlns:a="http://schemas.openxmlformats.org/drawingml/2006/main"/>
-          <a:lstStyle xmlns:a="http://schemas.openxmlformats.org/drawingml/2006/main">
-            <a:defPPr>
-              <a:defRPr sz="2400" b="1">
-                <a:solidFill>
-                  <a:srgbClr val="B74219"/>
-                </a:solidFill>
-                <a:latin typeface="Arial"/>
-                <a:ea typeface="Arial"/>
-                <a:cs typeface="Arial"/>
-              </a:defRPr>
-            </a:defPPr>
-            <a:lvl1pPr>
-              <a:defRPr sz="2400" b="1">
-                <a:solidFill>
-                  <a:srgbClr val="B74219"/>
-                </a:solidFill>
-                <a:latin typeface="Arial"/>
-                <a:ea typeface="Arial"/>
-                <a:cs typeface="Arial"/>
-              </a:defRPr>
-            </a:lvl1pPr>
-            <a:lvl2pPr>
-              <a:defRPr sz="2400" b="1">
-                <a:solidFill>
-                  <a:srgbClr val="B74219"/>
-                </a:solidFill>
-                <a:latin typeface="Arial"/>
-                <a:ea typeface="Arial"/>
-                <a:cs typeface="Arial"/>
-              </a:defRPr>
-            </a:lvl2pPr>
-            <a:lvl3pPr>
-              <a:defRPr sz="2400" b="1">
-                <a:solidFill>
-                  <a:srgbClr val="B74219"/>
-                </a:solidFill>
-                <a:latin typeface="Arial"/>
-                <a:ea typeface="Arial"/>
-                <a:cs typeface="Arial"/>
-              </a:defRPr>
-            </a:lvl3pPr>
-            <a:lvl4pPr>
-              <a:defRPr sz="2400" b="1">
-                <a:solidFill>
-                  <a:srgbClr val="B74219"/>
-                </a:solidFill>
-                <a:latin typeface="Arial"/>
-                <a:ea typeface="Arial"/>
-                <a:cs typeface="Arial"/>
-              </a:defRPr>
-            </a:lvl4pPr>
-            <a:lvl5pPr>
-              <a:defRPr sz="2400" b="1">
-                <a:solidFill>
-                  <a:srgbClr val="B74219"/>
-                </a:solidFill>
-                <a:latin typeface="Arial"/>
-                <a:ea typeface="Arial"/>
-                <a:cs typeface="Arial"/>
-              </a:defRPr>
-            </a:lvl5pPr>
-            <a:lvl6pPr>
-              <a:defRPr sz="2400" b="1">
-                <a:solidFill>
-                  <a:srgbClr val="B74219"/>
-                </a:solidFill>
-                <a:latin typeface="Arial"/>
-                <a:ea typeface="Arial"/>
-                <a:cs typeface="Arial"/>
-              </a:defRPr>
-            </a:lvl6pPr>
-            <a:lvl7pPr>
-              <a:defRPr sz="2400" b="1">
-                <a:solidFill>
-                  <a:srgbClr val="B74219"/>
-                </a:solidFill>
-                <a:latin typeface="Arial"/>
-                <a:ea typeface="Arial"/>
-                <a:cs typeface="Arial"/>
-              </a:defRPr>
-            </a:lvl7pPr>
-            <a:lvl8pPr>
-              <a:defRPr sz="2400" b="1">
-                <a:solidFill>
-                  <a:srgbClr val="B74219"/>
-                </a:solidFill>
-                <a:latin typeface="Arial"/>
-                <a:ea typeface="Arial"/>
-                <a:cs typeface="Arial"/>
-              </a:defRPr>
-            </a:lvl8pPr>
-            <a:lvl9pPr>
-              <a:defRPr sz="2400" b="1">
-                <a:solidFill>
-                  <a:srgbClr val="B74219"/>
-                </a:solidFill>
-                <a:latin typeface="Arial"/>
-                <a:ea typeface="Arial"/>
-                <a:cs typeface="Arial"/>
-              </a:defRPr>
-            </a:lvl9pPr>
-          </a:lstStyle>
-          <a:p xmlns:a="http://schemas.openxmlformats.org/drawingml/2006/main">
-            <a:pPr>
-              <a:defRPr sz="2400" b="1">
-                <a:solidFill>
-                  <a:srgbClr val="B74219"/>
-                </a:solidFill>
-                <a:latin typeface="Arial"/>
-                <a:ea typeface="Arial"/>
-                <a:cs typeface="Arial"/>
-              </a:defRPr>
-            </a:pPr>
-            <a:r>
-              <a:rPr sz="2400" b="1">
-                <a:solidFill>
-                  <a:srgbClr val="B74219"/>
-                </a:solidFill>
-                <a:latin typeface="Arial"/>
-                <a:ea typeface="Arial"/>
-                <a:cs typeface="Arial"/>
-              </a:rPr>
-              <a:t>Kết quả và dữ liệu gốc</a:t>
-            </a:r>
-          </a:p>
-        </p:txBody>
-      </p:sp>
-      <p:sp>
-        <p:nvSpPr>
-          <p:cNvPr id="8" name="">
-            <a:extLst xmlns:a="http://schemas.openxmlformats.org/drawingml/2006/main">
-              <a:ext uri="{FF2B5EF4-FFF2-40B4-BE49-F238E27FC236}">
-                <a16:creationId xmlns:a16="http://schemas.microsoft.com/office/drawing/2014/main" id="{649E813C-3C1D-4EA0-98B4-789FFB391634}"/>
-              </a:ext>
-            </a:extLst>
-          </p:cNvPr>
-          <p:cNvSpPr>
-            <a:spLocks xmlns:a="http://schemas.openxmlformats.org/drawingml/2006/main" noGrp="1"/>
-          </p:cNvSpPr>
-          <p:nvPr/>
-        </p:nvSpPr>
-        <p:spPr>
-          <a:xfrm xmlns:a="http://schemas.openxmlformats.org/drawingml/2006/main">
-            <a:off x="609600" y="4667250"/>
-            <a:ext cx="10953750" cy="476250"/>
-          </a:xfrm>
-          <a:prstGeom xmlns:a="http://schemas.openxmlformats.org/drawingml/2006/main" prst="rect">
-            <a:avLst/>
-          </a:prstGeom>
-          <a:noFill xmlns:a="http://schemas.openxmlformats.org/drawingml/2006/main"/>
-          <a:ln xmlns:a="http://schemas.openxmlformats.org/drawingml/2006/main" w="0">
-            <a:noFill/>
-          </a:ln>
-        </p:spPr>
-        <p:txBody>
-          <a:bodyPr xmlns:a="http://schemas.openxmlformats.org/drawingml/2006/main"/>
-          <a:lstStyle xmlns:a="http://schemas.openxmlformats.org/drawingml/2006/main">
-            <a:defPPr>
-              <a:defRPr sz="2100" b="0">
-                <a:solidFill>
-                  <a:srgbClr val="19232F"/>
-                </a:solidFill>
-                <a:latin typeface="Arial"/>
-                <a:ea typeface="Arial"/>
-                <a:cs typeface="Arial"/>
-              </a:defRPr>
-            </a:defPPr>
-            <a:lvl1pPr>
-              <a:defRPr sz="2100" b="0">
-                <a:solidFill>
-                  <a:srgbClr val="19232F"/>
-                </a:solidFill>
-                <a:latin typeface="Arial"/>
-                <a:ea typeface="Arial"/>
-                <a:cs typeface="Arial"/>
-              </a:defRPr>
-            </a:lvl1pPr>
-            <a:lvl2pPr>
-              <a:defRPr sz="2100" b="0">
-                <a:solidFill>
-                  <a:srgbClr val="19232F"/>
-                </a:solidFill>
-                <a:latin typeface="Arial"/>
-                <a:ea typeface="Arial"/>
-                <a:cs typeface="Arial"/>
-              </a:defRPr>
-            </a:lvl2pPr>
-            <a:lvl3pPr>
-              <a:defRPr sz="2100" b="0">
-                <a:solidFill>
-                  <a:srgbClr val="19232F"/>
-                </a:solidFill>
-                <a:latin typeface="Arial"/>
-                <a:ea typeface="Arial"/>
-                <a:cs typeface="Arial"/>
-              </a:defRPr>
-            </a:lvl3pPr>
-            <a:lvl4pPr>
-              <a:defRPr sz="2100" b="0">
-                <a:solidFill>
-                  <a:srgbClr val="19232F"/>
-                </a:solidFill>
-                <a:latin typeface="Arial"/>
-                <a:ea typeface="Arial"/>
-                <a:cs typeface="Arial"/>
-              </a:defRPr>
-            </a:lvl4pPr>
-            <a:lvl5pPr>
-              <a:defRPr sz="2100" b="0">
-                <a:solidFill>
-                  <a:srgbClr val="19232F"/>
-                </a:solidFill>
-                <a:latin typeface="Arial"/>
-                <a:ea typeface="Arial"/>
-                <a:cs typeface="Arial"/>
-              </a:defRPr>
-            </a:lvl5pPr>
-            <a:lvl6pPr>
-              <a:defRPr sz="2100" b="0">
-                <a:solidFill>
-                  <a:srgbClr val="19232F"/>
-                </a:solidFill>
-                <a:latin typeface="Arial"/>
-                <a:ea typeface="Arial"/>
-                <a:cs typeface="Arial"/>
-              </a:defRPr>
-            </a:lvl6pPr>
-            <a:lvl7pPr>
-              <a:defRPr sz="2100" b="0">
-                <a:solidFill>
-                  <a:srgbClr val="19232F"/>
-                </a:solidFill>
-                <a:latin typeface="Arial"/>
-                <a:ea typeface="Arial"/>
-                <a:cs typeface="Arial"/>
-              </a:defRPr>
-            </a:lvl7pPr>
-            <a:lvl8pPr>
-              <a:defRPr sz="2100" b="0">
-                <a:solidFill>
-                  <a:srgbClr val="19232F"/>
-                </a:solidFill>
-                <a:latin typeface="Arial"/>
-                <a:ea typeface="Arial"/>
-                <a:cs typeface="Arial"/>
-              </a:defRPr>
-            </a:lvl8pPr>
-            <a:lvl9pPr>
-              <a:defRPr sz="2100" b="0">
-                <a:solidFill>
-                  <a:srgbClr val="19232F"/>
-                </a:solidFill>
-                <a:latin typeface="Arial"/>
-                <a:ea typeface="Arial"/>
-                <a:cs typeface="Arial"/>
-              </a:defRPr>
-            </a:lvl9pPr>
-          </a:lstStyle>
-          <a:p xmlns:a="http://schemas.openxmlformats.org/drawingml/2006/main">
-            <a:pPr>
-              <a:defRPr sz="2100" b="0">
-                <a:solidFill>
-                  <a:srgbClr val="19232F"/>
-                </a:solidFill>
-                <a:latin typeface="Arial"/>
-                <a:ea typeface="Arial"/>
-                <a:cs typeface="Arial"/>
-              </a:defRPr>
-            </a:pPr>
-            <a:r>
-              <a:rPr sz="2100" b="0">
-                <a:solidFill>
-                  <a:srgbClr val="19232F"/>
-                </a:solidFill>
-                <a:latin typeface="Arial"/>
-                <a:ea typeface="Arial"/>
-                <a:cs typeface="Arial"/>
-              </a:rPr>
-              <a:t>manhld424.github.io/M38-Edge-PreLabeling/results.html</a:t>
-            </a:r>
-          </a:p>
-        </p:txBody>
-      </p:sp>
-      <p:sp>
-        <p:nvSpPr>
-          <p:cNvPr id="9" name="">
-            <a:extLst xmlns:a="http://schemas.openxmlformats.org/drawingml/2006/main">
-              <a:ext uri="{FF2B5EF4-FFF2-40B4-BE49-F238E27FC236}">
-                <a16:creationId xmlns:a16="http://schemas.microsoft.com/office/drawing/2014/main" id="{A23C4F7E-5190-4D96-980B-CB3F7ED594D3}"/>
-              </a:ext>
-            </a:extLst>
-          </p:cNvPr>
-          <p:cNvSpPr>
-            <a:spLocks xmlns:a="http://schemas.openxmlformats.org/drawingml/2006/main" noGrp="1"/>
-          </p:cNvSpPr>
-          <p:nvPr/>
-        </p:nvSpPr>
-        <p:spPr>
-          <a:xfrm xmlns:a="http://schemas.openxmlformats.org/drawingml/2006/main">
-            <a:off x="609600" y="5524500"/>
-            <a:ext cx="10953750" cy="762000"/>
-          </a:xfrm>
-          <a:prstGeom xmlns:a="http://schemas.openxmlformats.org/drawingml/2006/main" prst="rect">
-            <a:avLst/>
-          </a:prstGeom>
-          <a:noFill xmlns:a="http://schemas.openxmlformats.org/drawingml/2006/main"/>
-          <a:ln xmlns:a="http://schemas.openxmlformats.org/drawingml/2006/main" w="0">
-            <a:noFill/>
-          </a:ln>
-        </p:spPr>
-        <p:txBody>
-          <a:bodyPr xmlns:a="http://schemas.openxmlformats.org/drawingml/2006/main"/>
-          <a:lstStyle xmlns:a="http://schemas.openxmlformats.org/drawingml/2006/main">
-            <a:defPPr>
-              <a:defRPr sz="2175" b="0">
-                <a:solidFill>
-                  <a:srgbClr val="596675"/>
-                </a:solidFill>
-                <a:latin typeface="Arial"/>
-                <a:ea typeface="Arial"/>
-                <a:cs typeface="Arial"/>
-              </a:defRPr>
-            </a:defPPr>
-            <a:lvl1pPr>
-              <a:defRPr sz="2175" b="0">
-                <a:solidFill>
-                  <a:srgbClr val="596675"/>
-                </a:solidFill>
-                <a:latin typeface="Arial"/>
-                <a:ea typeface="Arial"/>
-                <a:cs typeface="Arial"/>
-              </a:defRPr>
-            </a:lvl1pPr>
-            <a:lvl2pPr>
-              <a:defRPr sz="2175" b="0">
-                <a:solidFill>
-                  <a:srgbClr val="596675"/>
-                </a:solidFill>
-                <a:latin typeface="Arial"/>
-                <a:ea typeface="Arial"/>
-                <a:cs typeface="Arial"/>
-              </a:defRPr>
-            </a:lvl2pPr>
-            <a:lvl3pPr>
-              <a:defRPr sz="2175" b="0">
-                <a:solidFill>
-                  <a:srgbClr val="596675"/>
-                </a:solidFill>
-                <a:latin typeface="Arial"/>
-                <a:ea typeface="Arial"/>
-                <a:cs typeface="Arial"/>
-              </a:defRPr>
-            </a:lvl3pPr>
-            <a:lvl4pPr>
-              <a:defRPr sz="2175" b="0">
-                <a:solidFill>
-                  <a:srgbClr val="596675"/>
-                </a:solidFill>
-                <a:latin typeface="Arial"/>
-                <a:ea typeface="Arial"/>
-                <a:cs typeface="Arial"/>
-              </a:defRPr>
-            </a:lvl4pPr>
-            <a:lvl5pPr>
-              <a:defRPr sz="2175" b="0">
-                <a:solidFill>
-                  <a:srgbClr val="596675"/>
-                </a:solidFill>
-                <a:latin typeface="Arial"/>
-                <a:ea typeface="Arial"/>
-                <a:cs typeface="Arial"/>
-              </a:defRPr>
-            </a:lvl5pPr>
-            <a:lvl6pPr>
-              <a:defRPr sz="2175" b="0">
-                <a:solidFill>
-                  <a:srgbClr val="596675"/>
-                </a:solidFill>
-                <a:latin typeface="Arial"/>
-                <a:ea typeface="Arial"/>
-                <a:cs typeface="Arial"/>
-              </a:defRPr>
-            </a:lvl6pPr>
-            <a:lvl7pPr>
-              <a:defRPr sz="2175" b="0">
-                <a:solidFill>
-                  <a:srgbClr val="596675"/>
-                </a:solidFill>
-                <a:latin typeface="Arial"/>
-                <a:ea typeface="Arial"/>
-                <a:cs typeface="Arial"/>
-              </a:defRPr>
-            </a:lvl7pPr>
-            <a:lvl8pPr>
-              <a:defRPr sz="2175" b="0">
-                <a:solidFill>
-                  <a:srgbClr val="596675"/>
-                </a:solidFill>
-                <a:latin typeface="Arial"/>
-                <a:ea typeface="Arial"/>
-                <a:cs typeface="Arial"/>
-              </a:defRPr>
-            </a:lvl8pPr>
-            <a:lvl9pPr>
-              <a:defRPr sz="2175" b="0">
-                <a:solidFill>
-                  <a:srgbClr val="596675"/>
-                </a:solidFill>
-                <a:latin typeface="Arial"/>
-                <a:ea typeface="Arial"/>
-                <a:cs typeface="Arial"/>
-              </a:defRPr>
-            </a:lvl9pPr>
-          </a:lstStyle>
-          <a:p xmlns:a="http://schemas.openxmlformats.org/drawingml/2006/main">
-            <a:pPr>
-              <a:defRPr sz="2175" b="0">
-                <a:solidFill>
-                  <a:srgbClr val="596675"/>
-                </a:solidFill>
-                <a:latin typeface="Arial"/>
-                <a:ea typeface="Arial"/>
-                <a:cs typeface="Arial"/>
-              </a:defRPr>
-            </a:pPr>
-            <a:r>
-              <a:rPr sz="2175" b="0">
-                <a:solidFill>
-                  <a:srgbClr val="596675"/>
-                </a:solidFill>
-                <a:latin typeface="Arial"/>
-                <a:ea typeface="Arial"/>
-                <a:cs typeface="Arial"/>
-              </a:rPr>
-              <a:t>Tiếp theo: mAP trên GT độc lập, RAM đỉnh, pilot annotator</a:t>
-            </a:r>
-          </a:p>
-          <a:p xmlns:a="http://schemas.openxmlformats.org/drawingml/2006/main">
-            <a:pPr>
-              <a:defRPr sz="2175" b="0">
-                <a:solidFill>
-                  <a:srgbClr val="596675"/>
-                </a:solidFill>
-                <a:latin typeface="Arial"/>
-                <a:ea typeface="Arial"/>
-                <a:cs typeface="Arial"/>
-              </a:defRPr>
-            </a:pPr>
-            <a:r>
-              <a:rPr sz="2175" b="0">
-                <a:solidFill>
-                  <a:srgbClr val="596675"/>
-                </a:solidFill>
-                <a:latin typeface="Arial"/>
-                <a:ea typeface="Arial"/>
-                <a:cs typeface="Arial"/>
-              </a:rPr>
-              <a:t>và CVAT import/save/reload trên server thật.</a:t>
-            </a:r>
-          </a:p>
-        </p:txBody>
-      </p:sp>
-    </p:spTree>
-    <p:extLst>
-      <p:ext uri="{BB962C8B-B14F-4D97-AF65-F5344CB8AC3E}">
-        <p14:creationId xmlns:p14="http://schemas.microsoft.com/office/powerpoint/2010/main" val="1560110084"/>
+        <p14:creationId xmlns:p14="http://schemas.microsoft.com/office/powerpoint/2010/main" val="1246013037"/>
       </p:ext>
     </p:extLst>
   </p:cSld>

</xml_diff>